<commit_message>
Restore red workshop style and complete participant instructions
</commit_message>
<xml_diff>
--- a/presentations/mapexport-workshop-merged.pptx
+++ b/presentations/mapexport-workshop-merged.pptx
@@ -2337,7 +2337,7 @@
     <p:bg>
       <p:bgPr>
         <a:solidFill>
-          <a:srgbClr val="FEF9E4"/>
+          <a:srgbClr val="F4501E"/>
         </a:solidFill>
       </p:bgPr>
     </p:bg>
@@ -2352,10 +2352,10 @@
       </p:grpSpPr>
       <p:sp>
         <p:nvSpPr>
-          <p:cNvPr id="18" name="">
-            <a:extLst>
-              <a:ext uri="{FF2B5EF4-FFF2-40B4-BE49-F238E27FC236}">
-                <a16:creationId xmlns:a16="http://schemas.microsoft.com/office/drawing/2014/main" id="{131C4ECF-AB7C-4405-8D50-9B3408112567}"/>
+          <p:cNvPr id="30" name="">
+            <a:extLst>
+              <a:ext uri="{FF2B5EF4-FFF2-40B4-BE49-F238E27FC236}">
+                <a16:creationId xmlns:a16="http://schemas.microsoft.com/office/drawing/2014/main" id="{313B1129-A1B4-49C6-9387-FF25FD15A669}"/>
               </a:ext>
             </a:extLst>
           </p:cNvPr>
@@ -2386,7 +2386,7 @@
             <a:pPr>
               <a:defRPr sz="1275" b="1">
                 <a:solidFill>
-                  <a:srgbClr val="F4501E"/>
+                  <a:srgbClr val="FEF9E4"/>
                 </a:solidFill>
                 <a:latin typeface="Apfel Grotezk"/>
                 <a:ea typeface="Apfel Grotezk"/>
@@ -2396,7 +2396,7 @@
             <a:r>
               <a:rPr sz="1275" b="1">
                 <a:solidFill>
-                  <a:srgbClr val="F4501E"/>
+                  <a:srgbClr val="FEF9E4"/>
                 </a:solidFill>
                 <a:latin typeface="Apfel Grotezk"/>
                 <a:ea typeface="Apfel Grotezk"/>
@@ -2412,7 +2412,7 @@
           <p:cNvPr id="2" name="">
             <a:extLst>
               <a:ext uri="{FF2B5EF4-FFF2-40B4-BE49-F238E27FC236}">
-                <a16:creationId xmlns:a16="http://schemas.microsoft.com/office/drawing/2014/main" id="{B8A92F86-0B6F-4083-A5F5-667A161BCEB8}"/>
+                <a16:creationId xmlns:a16="http://schemas.microsoft.com/office/drawing/2014/main" id="{4ACBC1E1-8B4B-41C3-B94E-C0F47EDE86C7}"/>
               </a:ext>
             </a:extLst>
           </p:cNvPr>
@@ -2443,7 +2443,7 @@
             <a:pPr>
               <a:defRPr sz="4125" b="0">
                 <a:solidFill>
-                  <a:srgbClr val="18180F"/>
+                  <a:srgbClr val="FEF9E4"/>
                 </a:solidFill>
                 <a:latin typeface="Mayonnaise Black"/>
                 <a:ea typeface="Mayonnaise Black"/>
@@ -2453,7 +2453,7 @@
             <a:r>
               <a:rPr sz="4125" b="0">
                 <a:solidFill>
-                  <a:srgbClr val="18180F"/>
+                  <a:srgbClr val="FEF9E4"/>
                 </a:solidFill>
                 <a:latin typeface="Mayonnaise Black"/>
                 <a:ea typeface="Mayonnaise Black"/>
@@ -2469,7 +2469,7 @@
           <p:cNvPr id="3" name="">
             <a:extLst>
               <a:ext uri="{FF2B5EF4-FFF2-40B4-BE49-F238E27FC236}">
-                <a16:creationId xmlns:a16="http://schemas.microsoft.com/office/drawing/2014/main" id="{6008B40F-D493-4CC8-987D-ED71A12868A7}"/>
+                <a16:creationId xmlns:a16="http://schemas.microsoft.com/office/drawing/2014/main" id="{C518F514-4B5C-4FD2-B1F1-142B41CFE9A1}"/>
               </a:ext>
             </a:extLst>
           </p:cNvPr>
@@ -2500,7 +2500,7 @@
             <a:pPr>
               <a:defRPr sz="1125" b="0">
                 <a:solidFill>
-                  <a:srgbClr val="18180F"/>
+                  <a:srgbClr val="FEF9E4"/>
                 </a:solidFill>
                 <a:latin typeface="Apfel Grotezk"/>
                 <a:ea typeface="Apfel Grotezk"/>
@@ -2510,7 +2510,7 @@
             <a:r>
               <a:rPr sz="1125" b="0">
                 <a:solidFill>
-                  <a:srgbClr val="18180F"/>
+                  <a:srgbClr val="FEF9E4"/>
                 </a:solidFill>
                 <a:latin typeface="Apfel Grotezk"/>
                 <a:ea typeface="Apfel Grotezk"/>
@@ -2526,7 +2526,7 @@
           <p:cNvPr id="4" name="">
             <a:extLst>
               <a:ext uri="{FF2B5EF4-FFF2-40B4-BE49-F238E27FC236}">
-                <a16:creationId xmlns:a16="http://schemas.microsoft.com/office/drawing/2014/main" id="{F3C36978-2D8C-43CA-BFEA-9A38C6CA66C6}"/>
+                <a16:creationId xmlns:a16="http://schemas.microsoft.com/office/drawing/2014/main" id="{71D06FBD-138D-418A-BF03-C7997D771BE6}"/>
               </a:ext>
             </a:extLst>
           </p:cNvPr>
@@ -2557,7 +2557,7 @@
             <a:pPr>
               <a:defRPr sz="1125" b="0">
                 <a:solidFill>
-                  <a:srgbClr val="18180F"/>
+                  <a:srgbClr val="FEF9E4"/>
                 </a:solidFill>
                 <a:latin typeface="Apfel Grotezk"/>
                 <a:ea typeface="Apfel Grotezk"/>
@@ -2567,7 +2567,7 @@
             <a:r>
               <a:rPr sz="1125" b="0">
                 <a:solidFill>
-                  <a:srgbClr val="18180F"/>
+                  <a:srgbClr val="FEF9E4"/>
                 </a:solidFill>
                 <a:latin typeface="Apfel Grotezk"/>
                 <a:ea typeface="Apfel Grotezk"/>
@@ -2583,48 +2583,48 @@
           <p:cNvPr id="5" name="">
             <a:extLst>
               <a:ext uri="{FF2B5EF4-FFF2-40B4-BE49-F238E27FC236}">
-                <a16:creationId xmlns:a16="http://schemas.microsoft.com/office/drawing/2014/main" id="{1C087409-BD2C-44CA-BD5A-ABBBA53447DB}"/>
-              </a:ext>
-            </a:extLst>
-          </p:cNvPr>
-          <p:cNvSpPr>
-            <a:spLocks noGrp="1"/>
-          </p:cNvSpPr>
-          <p:nvPr/>
-        </p:nvSpPr>
-        <p:spPr>
-          <a:xfrm>
-            <a:off x="457200" y="1485900"/>
-            <a:ext cx="11049000" cy="514350"/>
-          </a:xfrm>
-          <a:prstGeom prst="rect">
-            <a:avLst/>
-          </a:prstGeom>
-          <a:noFill/>
-          <a:ln w="0">
-            <a:noFill/>
-          </a:ln>
-        </p:spPr>
-        <p:txBody>
-          <a:bodyPr>
-            <a:noAutofit/>
-          </a:bodyPr>
-          <a:lstStyle/>
-          <a:p>
-            <a:pPr>
-              <a:defRPr sz="2625" b="1">
-                <a:solidFill>
-                  <a:srgbClr val="F4501E"/>
-                </a:solidFill>
-                <a:latin typeface="Apfel Grotezk"/>
-                <a:ea typeface="Apfel Grotezk"/>
-                <a:cs typeface="Apfel Grotezk"/>
-              </a:defRPr>
-            </a:pPr>
-            <a:r>
-              <a:rPr sz="2625" b="1" u="sng">
-                <a:solidFill>
-                  <a:srgbClr val="F4501E"/>
+                <a16:creationId xmlns:a16="http://schemas.microsoft.com/office/drawing/2014/main" id="{B1D879E3-1215-4D29-87C5-4A3A7DF93C96}"/>
+              </a:ext>
+            </a:extLst>
+          </p:cNvPr>
+          <p:cNvSpPr>
+            <a:spLocks noGrp="1"/>
+          </p:cNvSpPr>
+          <p:nvPr/>
+        </p:nvSpPr>
+        <p:spPr>
+          <a:xfrm>
+            <a:off x="8096250" y="876300"/>
+            <a:ext cx="3638550" cy="457200"/>
+          </a:xfrm>
+          <a:prstGeom prst="rect">
+            <a:avLst/>
+          </a:prstGeom>
+          <a:noFill/>
+          <a:ln w="0">
+            <a:noFill/>
+          </a:ln>
+        </p:spPr>
+        <p:txBody>
+          <a:bodyPr>
+            <a:noAutofit/>
+          </a:bodyPr>
+          <a:lstStyle/>
+          <a:p>
+            <a:pPr>
+              <a:defRPr sz="2175" b="1">
+                <a:solidFill>
+                  <a:srgbClr val="FEF9E4"/>
+                </a:solidFill>
+                <a:latin typeface="Apfel Grotezk"/>
+                <a:ea typeface="Apfel Grotezk"/>
+                <a:cs typeface="Apfel Grotezk"/>
+              </a:defRPr>
+            </a:pPr>
+            <a:r>
+              <a:rPr sz="2175" b="1" u="sng">
+                <a:solidFill>
+                  <a:srgbClr val="FEF9E4"/>
                 </a:solidFill>
                 <a:latin typeface="Apfel Grotezk"/>
                 <a:ea typeface="Apfel Grotezk"/>
@@ -2641,38 +2641,182 @@
           <p:cNvPr id="6" name="">
             <a:extLst>
               <a:ext uri="{FF2B5EF4-FFF2-40B4-BE49-F238E27FC236}">
-                <a16:creationId xmlns:a16="http://schemas.microsoft.com/office/drawing/2014/main" id="{89D0D3D8-786A-456B-8FA2-144E82F4E15E}"/>
-              </a:ext>
-            </a:extLst>
-          </p:cNvPr>
-          <p:cNvSpPr>
-            <a:spLocks noGrp="1"/>
-          </p:cNvSpPr>
-          <p:nvPr/>
-        </p:nvSpPr>
-        <p:spPr>
-          <a:xfrm>
-            <a:off x="457200" y="2219325"/>
-            <a:ext cx="685800" cy="552450"/>
-          </a:xfrm>
-          <a:prstGeom prst="rect">
-            <a:avLst/>
-          </a:prstGeom>
-          <a:noFill/>
-          <a:ln w="0">
-            <a:noFill/>
-          </a:ln>
-        </p:spPr>
-        <p:txBody>
-          <a:bodyPr>
-            <a:noAutofit/>
-          </a:bodyPr>
-          <a:lstStyle/>
-          <a:p>
-            <a:pPr>
-              <a:defRPr sz="3000" b="0">
-                <a:solidFill>
-                  <a:srgbClr val="F4501E"/>
+                <a16:creationId xmlns:a16="http://schemas.microsoft.com/office/drawing/2014/main" id="{F06C7D5E-7A17-4B89-9C5B-780A239463C2}"/>
+              </a:ext>
+            </a:extLst>
+          </p:cNvPr>
+          <p:cNvSpPr>
+            <a:spLocks noGrp="1"/>
+          </p:cNvSpPr>
+          <p:nvPr/>
+        </p:nvSpPr>
+        <p:spPr>
+          <a:xfrm>
+            <a:off x="457200" y="1514475"/>
+            <a:ext cx="7029450" cy="438150"/>
+          </a:xfrm>
+          <a:prstGeom prst="rect">
+            <a:avLst/>
+          </a:prstGeom>
+          <a:noFill/>
+          <a:ln w="0">
+            <a:noFill/>
+          </a:ln>
+        </p:spPr>
+        <p:txBody>
+          <a:bodyPr>
+            <a:noAutofit/>
+          </a:bodyPr>
+          <a:lstStyle/>
+          <a:p>
+            <a:pPr>
+              <a:defRPr sz="2025" b="1">
+                <a:solidFill>
+                  <a:srgbClr val="FEF9E4"/>
+                </a:solidFill>
+                <a:latin typeface="Apfel Grotezk"/>
+                <a:ea typeface="Apfel Grotezk"/>
+                <a:cs typeface="Apfel Grotezk"/>
+              </a:defRPr>
+            </a:pPr>
+            <a:r>
+              <a:rPr sz="2025" b="1">
+                <a:solidFill>
+                  <a:srgbClr val="FEF9E4"/>
+                </a:solidFill>
+                <a:latin typeface="Apfel Grotezk"/>
+                <a:ea typeface="Apfel Grotezk"/>
+                <a:cs typeface="Apfel Grotezk"/>
+              </a:rPr>
+              <a:t>COMPLETE THESE FOUR STEPS</a:t>
+            </a:r>
+          </a:p>
+        </p:txBody>
+      </p:sp>
+      <p:sp>
+        <p:nvSpPr>
+          <p:cNvPr id="7" name="">
+            <a:extLst>
+              <a:ext uri="{FF2B5EF4-FFF2-40B4-BE49-F238E27FC236}">
+                <a16:creationId xmlns:a16="http://schemas.microsoft.com/office/drawing/2014/main" id="{69C583B5-3C16-41E1-92CD-6E1C056CEC7C}"/>
+              </a:ext>
+            </a:extLst>
+          </p:cNvPr>
+          <p:cNvSpPr>
+            <a:spLocks noGrp="1"/>
+          </p:cNvSpPr>
+          <p:nvPr/>
+        </p:nvSpPr>
+        <p:spPr>
+          <a:xfrm>
+            <a:off x="7962900" y="1514475"/>
+            <a:ext cx="3771900" cy="438150"/>
+          </a:xfrm>
+          <a:prstGeom prst="rect">
+            <a:avLst/>
+          </a:prstGeom>
+          <a:noFill/>
+          <a:ln w="0">
+            <a:noFill/>
+          </a:ln>
+        </p:spPr>
+        <p:txBody>
+          <a:bodyPr>
+            <a:noAutofit/>
+          </a:bodyPr>
+          <a:lstStyle/>
+          <a:p>
+            <a:pPr>
+              <a:defRPr sz="2025" b="1">
+                <a:solidFill>
+                  <a:srgbClr val="FEF9E4"/>
+                </a:solidFill>
+                <a:latin typeface="Apfel Grotezk"/>
+                <a:ea typeface="Apfel Grotezk"/>
+                <a:cs typeface="Apfel Grotezk"/>
+              </a:defRPr>
+            </a:pPr>
+            <a:r>
+              <a:rPr sz="2025" b="1">
+                <a:solidFill>
+                  <a:srgbClr val="FEF9E4"/>
+                </a:solidFill>
+                <a:latin typeface="Apfel Grotezk"/>
+                <a:ea typeface="Apfel Grotezk"/>
+                <a:cs typeface="Apfel Grotezk"/>
+              </a:rPr>
+              <a:t>IF YOU GET STUCK</a:t>
+            </a:r>
+          </a:p>
+        </p:txBody>
+      </p:sp>
+      <p:sp>
+        <p:nvSpPr>
+          <p:cNvPr id="8" name="">
+            <a:extLst>
+              <a:ext uri="{FF2B5EF4-FFF2-40B4-BE49-F238E27FC236}">
+                <a16:creationId xmlns:a16="http://schemas.microsoft.com/office/drawing/2014/main" id="{9D3B05FB-69ED-41EA-A7FA-F37D4B7981BB}"/>
+              </a:ext>
+            </a:extLst>
+          </p:cNvPr>
+          <p:cNvSpPr>
+            <a:spLocks noGrp="1"/>
+          </p:cNvSpPr>
+          <p:nvPr/>
+        </p:nvSpPr>
+        <p:spPr>
+          <a:xfrm>
+            <a:off x="7629525" y="1609725"/>
+            <a:ext cx="19050" cy="3895725"/>
+          </a:xfrm>
+          <a:prstGeom prst="rect">
+            <a:avLst/>
+          </a:prstGeom>
+          <a:solidFill>
+            <a:srgbClr val="FEF9E4"/>
+          </a:solidFill>
+          <a:ln w="0">
+            <a:noFill/>
+          </a:ln>
+        </p:spPr>
+      </p:sp>
+      <p:sp>
+        <p:nvSpPr>
+          <p:cNvPr id="9" name="">
+            <a:extLst>
+              <a:ext uri="{FF2B5EF4-FFF2-40B4-BE49-F238E27FC236}">
+                <a16:creationId xmlns:a16="http://schemas.microsoft.com/office/drawing/2014/main" id="{0B604DB0-4280-4210-946A-DDA64BDFB77F}"/>
+              </a:ext>
+            </a:extLst>
+          </p:cNvPr>
+          <p:cNvSpPr>
+            <a:spLocks noGrp="1"/>
+          </p:cNvSpPr>
+          <p:nvPr/>
+        </p:nvSpPr>
+        <p:spPr>
+          <a:xfrm>
+            <a:off x="457200" y="2028825"/>
+            <a:ext cx="619125" cy="476250"/>
+          </a:xfrm>
+          <a:prstGeom prst="rect">
+            <a:avLst/>
+          </a:prstGeom>
+          <a:noFill/>
+          <a:ln w="0">
+            <a:noFill/>
+          </a:ln>
+        </p:spPr>
+        <p:txBody>
+          <a:bodyPr>
+            <a:noAutofit/>
+          </a:bodyPr>
+          <a:lstStyle/>
+          <a:p>
+            <a:pPr>
+              <a:defRPr sz="2550" b="0">
+                <a:solidFill>
+                  <a:srgbClr val="FEF9E4"/>
                 </a:solidFill>
                 <a:latin typeface="Mayonnaise Black"/>
                 <a:ea typeface="Mayonnaise Black"/>
@@ -2680,9 +2824,9 @@
               </a:defRPr>
             </a:pPr>
             <a:r>
-              <a:rPr sz="3000" b="0">
-                <a:solidFill>
-                  <a:srgbClr val="F4501E"/>
+              <a:rPr sz="2550" b="0">
+                <a:solidFill>
+                  <a:srgbClr val="FEF9E4"/>
                 </a:solidFill>
                 <a:latin typeface="Mayonnaise Black"/>
                 <a:ea typeface="Mayonnaise Black"/>
@@ -2695,51 +2839,51 @@
       </p:sp>
       <p:sp>
         <p:nvSpPr>
-          <p:cNvPr id="7" name="">
-            <a:extLst>
-              <a:ext uri="{FF2B5EF4-FFF2-40B4-BE49-F238E27FC236}">
-                <a16:creationId xmlns:a16="http://schemas.microsoft.com/office/drawing/2014/main" id="{6D77453F-B960-48B9-8093-20D41C202EC6}"/>
-              </a:ext>
-            </a:extLst>
-          </p:cNvPr>
-          <p:cNvSpPr>
-            <a:spLocks noGrp="1"/>
-          </p:cNvSpPr>
-          <p:nvPr/>
-        </p:nvSpPr>
-        <p:spPr>
-          <a:xfrm>
-            <a:off x="1257300" y="2219325"/>
-            <a:ext cx="10248900" cy="400050"/>
-          </a:xfrm>
-          <a:prstGeom prst="rect">
-            <a:avLst/>
-          </a:prstGeom>
-          <a:noFill/>
-          <a:ln w="0">
-            <a:noFill/>
-          </a:ln>
-        </p:spPr>
-        <p:txBody>
-          <a:bodyPr>
-            <a:noAutofit/>
-          </a:bodyPr>
-          <a:lstStyle/>
-          <a:p>
-            <a:pPr>
-              <a:defRPr sz="2250" b="1">
-                <a:solidFill>
-                  <a:srgbClr val="18180F"/>
-                </a:solidFill>
-                <a:latin typeface="Apfel Grotezk"/>
-                <a:ea typeface="Apfel Grotezk"/>
-                <a:cs typeface="Apfel Grotezk"/>
-              </a:defRPr>
-            </a:pPr>
-            <a:r>
-              <a:rPr sz="2250" b="1">
-                <a:solidFill>
-                  <a:srgbClr val="18180F"/>
+          <p:cNvPr id="10" name="">
+            <a:extLst>
+              <a:ext uri="{FF2B5EF4-FFF2-40B4-BE49-F238E27FC236}">
+                <a16:creationId xmlns:a16="http://schemas.microsoft.com/office/drawing/2014/main" id="{5E96EFBA-302C-465E-90EE-AB9F9AF32724}"/>
+              </a:ext>
+            </a:extLst>
+          </p:cNvPr>
+          <p:cNvSpPr>
+            <a:spLocks noGrp="1"/>
+          </p:cNvSpPr>
+          <p:nvPr/>
+        </p:nvSpPr>
+        <p:spPr>
+          <a:xfrm>
+            <a:off x="1133475" y="2028825"/>
+            <a:ext cx="6343650" cy="409575"/>
+          </a:xfrm>
+          <a:prstGeom prst="rect">
+            <a:avLst/>
+          </a:prstGeom>
+          <a:noFill/>
+          <a:ln w="0">
+            <a:noFill/>
+          </a:ln>
+        </p:spPr>
+        <p:txBody>
+          <a:bodyPr>
+            <a:noAutofit/>
+          </a:bodyPr>
+          <a:lstStyle/>
+          <a:p>
+            <a:pPr>
+              <a:defRPr sz="2100" b="1">
+                <a:solidFill>
+                  <a:srgbClr val="FEF9E4"/>
+                </a:solidFill>
+                <a:latin typeface="Apfel Grotezk"/>
+                <a:ea typeface="Apfel Grotezk"/>
+                <a:cs typeface="Apfel Grotezk"/>
+              </a:defRPr>
+            </a:pPr>
+            <a:r>
+              <a:rPr sz="2100" b="1">
+                <a:solidFill>
+                  <a:srgbClr val="FEF9E4"/>
                 </a:solidFill>
                 <a:latin typeface="Apfel Grotezk"/>
                 <a:ea typeface="Apfel Grotezk"/>
@@ -2752,98 +2896,98 @@
       </p:sp>
       <p:sp>
         <p:nvSpPr>
-          <p:cNvPr id="8" name="">
-            <a:extLst>
-              <a:ext uri="{FF2B5EF4-FFF2-40B4-BE49-F238E27FC236}">
-                <a16:creationId xmlns:a16="http://schemas.microsoft.com/office/drawing/2014/main" id="{3D0AEEF2-2A25-489F-B0F0-795CCEB8B19F}"/>
-              </a:ext>
-            </a:extLst>
-          </p:cNvPr>
-          <p:cNvSpPr>
-            <a:spLocks noGrp="1"/>
-          </p:cNvSpPr>
-          <p:nvPr/>
-        </p:nvSpPr>
-        <p:spPr>
-          <a:xfrm>
-            <a:off x="1257300" y="2657475"/>
-            <a:ext cx="10248900" cy="638175"/>
-          </a:xfrm>
-          <a:prstGeom prst="rect">
-            <a:avLst/>
-          </a:prstGeom>
-          <a:noFill/>
-          <a:ln w="0">
-            <a:noFill/>
-          </a:ln>
-        </p:spPr>
-        <p:txBody>
-          <a:bodyPr>
-            <a:noAutofit/>
-          </a:bodyPr>
-          <a:lstStyle/>
-          <a:p>
-            <a:pPr>
-              <a:defRPr sz="1950" b="0">
-                <a:solidFill>
-                  <a:srgbClr val="18180F"/>
-                </a:solidFill>
-                <a:latin typeface="Apfel Grotezk"/>
-                <a:ea typeface="Apfel Grotezk"/>
-                <a:cs typeface="Apfel Grotezk"/>
-              </a:defRPr>
-            </a:pPr>
-            <a:r>
-              <a:rPr sz="1950" b="0">
-                <a:solidFill>
-                  <a:srgbClr val="18180F"/>
-                </a:solidFill>
-                <a:latin typeface="Apfel Grotezk"/>
-                <a:ea typeface="Apfel Grotezk"/>
-                <a:cs typeface="Apfel Grotezk"/>
-              </a:rPr>
-              <a:t>Choose your SVG format. Open it in Illustrator or Inkscape.</a:t>
-            </a:r>
-          </a:p>
-        </p:txBody>
-      </p:sp>
-      <p:sp>
-        <p:nvSpPr>
-          <p:cNvPr id="9" name="">
-            <a:extLst>
-              <a:ext uri="{FF2B5EF4-FFF2-40B4-BE49-F238E27FC236}">
-                <a16:creationId xmlns:a16="http://schemas.microsoft.com/office/drawing/2014/main" id="{5944E4E6-E5E3-4FA4-8F57-EA13B3FE7F7F}"/>
-              </a:ext>
-            </a:extLst>
-          </p:cNvPr>
-          <p:cNvSpPr>
-            <a:spLocks noGrp="1"/>
-          </p:cNvSpPr>
-          <p:nvPr/>
-        </p:nvSpPr>
-        <p:spPr>
-          <a:xfrm>
-            <a:off x="457200" y="3314700"/>
-            <a:ext cx="685800" cy="552450"/>
-          </a:xfrm>
-          <a:prstGeom prst="rect">
-            <a:avLst/>
-          </a:prstGeom>
-          <a:noFill/>
-          <a:ln w="0">
-            <a:noFill/>
-          </a:ln>
-        </p:spPr>
-        <p:txBody>
-          <a:bodyPr>
-            <a:noAutofit/>
-          </a:bodyPr>
-          <a:lstStyle/>
-          <a:p>
-            <a:pPr>
-              <a:defRPr sz="3000" b="0">
-                <a:solidFill>
-                  <a:srgbClr val="F4501E"/>
+          <p:cNvPr id="11" name="">
+            <a:extLst>
+              <a:ext uri="{FF2B5EF4-FFF2-40B4-BE49-F238E27FC236}">
+                <a16:creationId xmlns:a16="http://schemas.microsoft.com/office/drawing/2014/main" id="{FC8848BC-6CCC-491A-9763-20FAFF972B48}"/>
+              </a:ext>
+            </a:extLst>
+          </p:cNvPr>
+          <p:cNvSpPr>
+            <a:spLocks noGrp="1"/>
+          </p:cNvSpPr>
+          <p:nvPr/>
+        </p:nvSpPr>
+        <p:spPr>
+          <a:xfrm>
+            <a:off x="1133475" y="2428875"/>
+            <a:ext cx="6276975" cy="628650"/>
+          </a:xfrm>
+          <a:prstGeom prst="rect">
+            <a:avLst/>
+          </a:prstGeom>
+          <a:noFill/>
+          <a:ln w="0">
+            <a:noFill/>
+          </a:ln>
+        </p:spPr>
+        <p:txBody>
+          <a:bodyPr>
+            <a:noAutofit/>
+          </a:bodyPr>
+          <a:lstStyle/>
+          <a:p>
+            <a:pPr>
+              <a:defRPr sz="1800" b="0">
+                <a:solidFill>
+                  <a:srgbClr val="FEF9E4"/>
+                </a:solidFill>
+                <a:latin typeface="Apfel Grotezk"/>
+                <a:ea typeface="Apfel Grotezk"/>
+                <a:cs typeface="Apfel Grotezk"/>
+              </a:defRPr>
+            </a:pPr>
+            <a:r>
+              <a:rPr sz="1800" b="0">
+                <a:solidFill>
+                  <a:srgbClr val="FEF9E4"/>
+                </a:solidFill>
+                <a:latin typeface="Apfel Grotezk"/>
+                <a:ea typeface="Apfel Grotezk"/>
+                <a:cs typeface="Apfel Grotezk"/>
+              </a:rPr>
+              <a:t>Open the SVG in Illustrator or Inkscape.</a:t>
+            </a:r>
+          </a:p>
+        </p:txBody>
+      </p:sp>
+      <p:sp>
+        <p:nvSpPr>
+          <p:cNvPr id="12" name="">
+            <a:extLst>
+              <a:ext uri="{FF2B5EF4-FFF2-40B4-BE49-F238E27FC236}">
+                <a16:creationId xmlns:a16="http://schemas.microsoft.com/office/drawing/2014/main" id="{4649209D-609F-490B-AA8C-C8CF56D394F5}"/>
+              </a:ext>
+            </a:extLst>
+          </p:cNvPr>
+          <p:cNvSpPr>
+            <a:spLocks noGrp="1"/>
+          </p:cNvSpPr>
+          <p:nvPr/>
+        </p:nvSpPr>
+        <p:spPr>
+          <a:xfrm>
+            <a:off x="457200" y="2933700"/>
+            <a:ext cx="619125" cy="476250"/>
+          </a:xfrm>
+          <a:prstGeom prst="rect">
+            <a:avLst/>
+          </a:prstGeom>
+          <a:noFill/>
+          <a:ln w="0">
+            <a:noFill/>
+          </a:ln>
+        </p:spPr>
+        <p:txBody>
+          <a:bodyPr>
+            <a:noAutofit/>
+          </a:bodyPr>
+          <a:lstStyle/>
+          <a:p>
+            <a:pPr>
+              <a:defRPr sz="2550" b="0">
+                <a:solidFill>
+                  <a:srgbClr val="FEF9E4"/>
                 </a:solidFill>
                 <a:latin typeface="Mayonnaise Black"/>
                 <a:ea typeface="Mayonnaise Black"/>
@@ -2851,9 +2995,9 @@
               </a:defRPr>
             </a:pPr>
             <a:r>
-              <a:rPr sz="3000" b="0">
-                <a:solidFill>
-                  <a:srgbClr val="F4501E"/>
+              <a:rPr sz="2550" b="0">
+                <a:solidFill>
+                  <a:srgbClr val="FEF9E4"/>
                 </a:solidFill>
                 <a:latin typeface="Mayonnaise Black"/>
                 <a:ea typeface="Mayonnaise Black"/>
@@ -2866,155 +3010,178 @@
       </p:sp>
       <p:sp>
         <p:nvSpPr>
-          <p:cNvPr id="10" name="">
-            <a:extLst>
-              <a:ext uri="{FF2B5EF4-FFF2-40B4-BE49-F238E27FC236}">
-                <a16:creationId xmlns:a16="http://schemas.microsoft.com/office/drawing/2014/main" id="{A142A9BD-575E-48BB-93BD-0CEF69FDDB34}"/>
-              </a:ext>
-            </a:extLst>
-          </p:cNvPr>
-          <p:cNvSpPr>
-            <a:spLocks noGrp="1"/>
-          </p:cNvSpPr>
-          <p:nvPr/>
-        </p:nvSpPr>
-        <p:spPr>
-          <a:xfrm>
-            <a:off x="1257300" y="3314700"/>
-            <a:ext cx="10248900" cy="400050"/>
-          </a:xfrm>
-          <a:prstGeom prst="rect">
-            <a:avLst/>
-          </a:prstGeom>
-          <a:noFill/>
-          <a:ln w="0">
-            <a:noFill/>
-          </a:ln>
-        </p:spPr>
-        <p:txBody>
-          <a:bodyPr>
-            <a:noAutofit/>
-          </a:bodyPr>
-          <a:lstStyle/>
-          <a:p>
-            <a:pPr>
-              <a:defRPr sz="2250" b="1">
-                <a:solidFill>
-                  <a:srgbClr val="18180F"/>
-                </a:solidFill>
-                <a:latin typeface="Apfel Grotezk"/>
-                <a:ea typeface="Apfel Grotezk"/>
-                <a:cs typeface="Apfel Grotezk"/>
-              </a:defRPr>
-            </a:pPr>
-            <a:r>
-              <a:rPr sz="2250" b="1">
-                <a:solidFill>
-                  <a:srgbClr val="18180F"/>
-                </a:solidFill>
-                <a:latin typeface="Apfel Grotezk"/>
-                <a:ea typeface="Apfel Grotezk"/>
-                <a:cs typeface="Apfel Grotezk"/>
-              </a:rPr>
-              <a:t>Explore and edit</a:t>
-            </a:r>
-          </a:p>
-        </p:txBody>
-      </p:sp>
-      <p:sp>
-        <p:nvSpPr>
-          <p:cNvPr id="11" name="">
-            <a:extLst>
-              <a:ext uri="{FF2B5EF4-FFF2-40B4-BE49-F238E27FC236}">
-                <a16:creationId xmlns:a16="http://schemas.microsoft.com/office/drawing/2014/main" id="{7B815380-A657-4F47-9F40-4FFC3D7A42D5}"/>
-              </a:ext>
-            </a:extLst>
-          </p:cNvPr>
-          <p:cNvSpPr>
-            <a:spLocks noGrp="1"/>
-          </p:cNvSpPr>
-          <p:nvPr/>
-        </p:nvSpPr>
-        <p:spPr>
-          <a:xfrm>
-            <a:off x="1257300" y="3752850"/>
-            <a:ext cx="10248900" cy="638175"/>
-          </a:xfrm>
-          <a:prstGeom prst="rect">
-            <a:avLst/>
-          </a:prstGeom>
-          <a:noFill/>
-          <a:ln w="0">
-            <a:noFill/>
-          </a:ln>
-        </p:spPr>
-        <p:txBody>
-          <a:bodyPr>
-            <a:noAutofit/>
-          </a:bodyPr>
-          <a:lstStyle/>
-          <a:p>
-            <a:pPr>
-              <a:defRPr sz="1950" b="0">
-                <a:solidFill>
-                  <a:srgbClr val="18180F"/>
-                </a:solidFill>
-                <a:latin typeface="Apfel Grotezk"/>
-                <a:ea typeface="Apfel Grotezk"/>
-                <a:cs typeface="Apfel Grotezk"/>
-              </a:defRPr>
-            </a:pPr>
-            <a:r>
-              <a:rPr sz="1950" b="0">
-                <a:solidFill>
-                  <a:srgbClr val="18180F"/>
-                </a:solidFill>
-                <a:latin typeface="Apfel Grotezk"/>
-                <a:ea typeface="Apfel Grotezk"/>
-                <a:cs typeface="Apfel Grotezk"/>
-              </a:rPr>
-              <a:t>Recolour the city blocks. Toggle a layer. Find a street label.</a:t>
-            </a:r>
-          </a:p>
-        </p:txBody>
-      </p:sp>
-      <p:sp>
-        <p:nvSpPr>
-          <p:cNvPr id="12" name="">
-            <a:extLst>
-              <a:ext uri="{FF2B5EF4-FFF2-40B4-BE49-F238E27FC236}">
-                <a16:creationId xmlns:a16="http://schemas.microsoft.com/office/drawing/2014/main" id="{0403257E-C99C-4C88-B2DB-90AF2D6495CF}"/>
-              </a:ext>
-            </a:extLst>
-          </p:cNvPr>
-          <p:cNvSpPr>
-            <a:spLocks noGrp="1"/>
-          </p:cNvSpPr>
-          <p:nvPr/>
-        </p:nvSpPr>
-        <p:spPr>
-          <a:xfrm>
-            <a:off x="457200" y="4410075"/>
-            <a:ext cx="685800" cy="552450"/>
-          </a:xfrm>
-          <a:prstGeom prst="rect">
-            <a:avLst/>
-          </a:prstGeom>
-          <a:noFill/>
-          <a:ln w="0">
-            <a:noFill/>
-          </a:ln>
-        </p:spPr>
-        <p:txBody>
-          <a:bodyPr>
-            <a:noAutofit/>
-          </a:bodyPr>
-          <a:lstStyle/>
-          <a:p>
-            <a:pPr>
-              <a:defRPr sz="3000" b="0">
-                <a:solidFill>
-                  <a:srgbClr val="F4501E"/>
+          <p:cNvPr id="13" name="">
+            <a:extLst>
+              <a:ext uri="{FF2B5EF4-FFF2-40B4-BE49-F238E27FC236}">
+                <a16:creationId xmlns:a16="http://schemas.microsoft.com/office/drawing/2014/main" id="{0300B703-FEC7-43E2-B08D-8061E49B60EB}"/>
+              </a:ext>
+            </a:extLst>
+          </p:cNvPr>
+          <p:cNvSpPr>
+            <a:spLocks noGrp="1"/>
+          </p:cNvSpPr>
+          <p:nvPr/>
+        </p:nvSpPr>
+        <p:spPr>
+          <a:xfrm>
+            <a:off x="1133475" y="2933700"/>
+            <a:ext cx="6343650" cy="409575"/>
+          </a:xfrm>
+          <a:prstGeom prst="rect">
+            <a:avLst/>
+          </a:prstGeom>
+          <a:noFill/>
+          <a:ln w="0">
+            <a:noFill/>
+          </a:ln>
+        </p:spPr>
+        <p:txBody>
+          <a:bodyPr>
+            <a:noAutofit/>
+          </a:bodyPr>
+          <a:lstStyle/>
+          <a:p>
+            <a:pPr>
+              <a:defRPr sz="2100" b="1">
+                <a:solidFill>
+                  <a:srgbClr val="FEF9E4"/>
+                </a:solidFill>
+                <a:latin typeface="Apfel Grotezk"/>
+                <a:ea typeface="Apfel Grotezk"/>
+                <a:cs typeface="Apfel Grotezk"/>
+              </a:defRPr>
+            </a:pPr>
+            <a:r>
+              <a:rPr sz="2100" b="1">
+                <a:solidFill>
+                  <a:srgbClr val="FEF9E4"/>
+                </a:solidFill>
+                <a:latin typeface="Apfel Grotezk"/>
+                <a:ea typeface="Apfel Grotezk"/>
+                <a:cs typeface="Apfel Grotezk"/>
+              </a:rPr>
+              <a:t>Recolour all city blocks</a:t>
+            </a:r>
+          </a:p>
+        </p:txBody>
+      </p:sp>
+      <p:sp>
+        <p:nvSpPr>
+          <p:cNvPr id="14" name="">
+            <a:extLst>
+              <a:ext uri="{FF2B5EF4-FFF2-40B4-BE49-F238E27FC236}">
+                <a16:creationId xmlns:a16="http://schemas.microsoft.com/office/drawing/2014/main" id="{6364A113-E7D0-4EE7-82EB-FA0D9BED97F0}"/>
+              </a:ext>
+            </a:extLst>
+          </p:cNvPr>
+          <p:cNvSpPr>
+            <a:spLocks noGrp="1"/>
+          </p:cNvSpPr>
+          <p:nvPr/>
+        </p:nvSpPr>
+        <p:spPr>
+          <a:xfrm>
+            <a:off x="1133475" y="3333750"/>
+            <a:ext cx="6276975" cy="628650"/>
+          </a:xfrm>
+          <a:prstGeom prst="rect">
+            <a:avLst/>
+          </a:prstGeom>
+          <a:noFill/>
+          <a:ln w="0">
+            <a:noFill/>
+          </a:ln>
+        </p:spPr>
+        <p:txBody>
+          <a:bodyPr>
+            <a:noAutofit/>
+          </a:bodyPr>
+          <a:lstStyle/>
+          <a:p>
+            <a:pPr>
+              <a:defRPr sz="1800" b="0">
+                <a:solidFill>
+                  <a:srgbClr val="FEF9E4"/>
+                </a:solidFill>
+                <a:latin typeface="Apfel Grotezk"/>
+                <a:ea typeface="Apfel Grotezk"/>
+                <a:cs typeface="Apfel Grotezk"/>
+              </a:defRPr>
+            </a:pPr>
+            <a:r>
+              <a:rPr sz="1800" b="0">
+                <a:solidFill>
+                  <a:srgbClr val="FEF9E4"/>
+                </a:solidFill>
+                <a:latin typeface="Apfel Grotezk"/>
+                <a:ea typeface="Apfel Grotezk"/>
+                <a:cs typeface="Apfel Grotezk"/>
+              </a:rPr>
+              <a:t>Select the block paths together. Keep roads</a:t>
+            </a:r>
+          </a:p>
+          <a:p>
+            <a:pPr>
+              <a:defRPr sz="1800" b="0">
+                <a:solidFill>
+                  <a:srgbClr val="FEF9E4"/>
+                </a:solidFill>
+                <a:latin typeface="Apfel Grotezk"/>
+                <a:ea typeface="Apfel Grotezk"/>
+                <a:cs typeface="Apfel Grotezk"/>
+              </a:defRPr>
+            </a:pPr>
+            <a:r>
+              <a:rPr sz="1800" b="0">
+                <a:solidFill>
+                  <a:srgbClr val="FEF9E4"/>
+                </a:solidFill>
+                <a:latin typeface="Apfel Grotezk"/>
+                <a:ea typeface="Apfel Grotezk"/>
+                <a:cs typeface="Apfel Grotezk"/>
+              </a:rPr>
+              <a:t>and water unchanged.</a:t>
+            </a:r>
+          </a:p>
+        </p:txBody>
+      </p:sp>
+      <p:sp>
+        <p:nvSpPr>
+          <p:cNvPr id="15" name="">
+            <a:extLst>
+              <a:ext uri="{FF2B5EF4-FFF2-40B4-BE49-F238E27FC236}">
+                <a16:creationId xmlns:a16="http://schemas.microsoft.com/office/drawing/2014/main" id="{98792274-7ACD-4102-B73F-40FD2D7EAE11}"/>
+              </a:ext>
+            </a:extLst>
+          </p:cNvPr>
+          <p:cNvSpPr>
+            <a:spLocks noGrp="1"/>
+          </p:cNvSpPr>
+          <p:nvPr/>
+        </p:nvSpPr>
+        <p:spPr>
+          <a:xfrm>
+            <a:off x="457200" y="3876675"/>
+            <a:ext cx="619125" cy="476250"/>
+          </a:xfrm>
+          <a:prstGeom prst="rect">
+            <a:avLst/>
+          </a:prstGeom>
+          <a:noFill/>
+          <a:ln w="0">
+            <a:noFill/>
+          </a:ln>
+        </p:spPr>
+        <p:txBody>
+          <a:bodyPr>
+            <a:noAutofit/>
+          </a:bodyPr>
+          <a:lstStyle/>
+          <a:p>
+            <a:pPr>
+              <a:defRPr sz="2550" b="0">
+                <a:solidFill>
+                  <a:srgbClr val="FEF9E4"/>
                 </a:solidFill>
                 <a:latin typeface="Mayonnaise Black"/>
                 <a:ea typeface="Mayonnaise Black"/>
@@ -3022,9 +3189,9 @@
               </a:defRPr>
             </a:pPr>
             <a:r>
-              <a:rPr sz="3000" b="0">
-                <a:solidFill>
-                  <a:srgbClr val="F4501E"/>
+              <a:rPr sz="2550" b="0">
+                <a:solidFill>
+                  <a:srgbClr val="FEF9E4"/>
                 </a:solidFill>
                 <a:latin typeface="Mayonnaise Black"/>
                 <a:ea typeface="Mayonnaise Black"/>
@@ -3037,51 +3204,222 @@
       </p:sp>
       <p:sp>
         <p:nvSpPr>
-          <p:cNvPr id="13" name="">
-            <a:extLst>
-              <a:ext uri="{FF2B5EF4-FFF2-40B4-BE49-F238E27FC236}">
-                <a16:creationId xmlns:a16="http://schemas.microsoft.com/office/drawing/2014/main" id="{9FF4B7F3-8EC5-41C3-BFDF-BC205CCB739C}"/>
-              </a:ext>
-            </a:extLst>
-          </p:cNvPr>
-          <p:cNvSpPr>
-            <a:spLocks noGrp="1"/>
-          </p:cNvSpPr>
-          <p:nvPr/>
-        </p:nvSpPr>
-        <p:spPr>
-          <a:xfrm>
-            <a:off x="1257300" y="4410075"/>
-            <a:ext cx="10248900" cy="400050"/>
-          </a:xfrm>
-          <a:prstGeom prst="rect">
-            <a:avLst/>
-          </a:prstGeom>
-          <a:noFill/>
-          <a:ln w="0">
-            <a:noFill/>
-          </a:ln>
-        </p:spPr>
-        <p:txBody>
-          <a:bodyPr>
-            <a:noAutofit/>
-          </a:bodyPr>
-          <a:lstStyle/>
-          <a:p>
-            <a:pPr>
-              <a:defRPr sz="2250" b="1">
-                <a:solidFill>
-                  <a:srgbClr val="18180F"/>
-                </a:solidFill>
-                <a:latin typeface="Apfel Grotezk"/>
-                <a:ea typeface="Apfel Grotezk"/>
-                <a:cs typeface="Apfel Grotezk"/>
-              </a:defRPr>
-            </a:pPr>
-            <a:r>
-              <a:rPr sz="2250" b="1">
-                <a:solidFill>
-                  <a:srgbClr val="18180F"/>
+          <p:cNvPr id="16" name="">
+            <a:extLst>
+              <a:ext uri="{FF2B5EF4-FFF2-40B4-BE49-F238E27FC236}">
+                <a16:creationId xmlns:a16="http://schemas.microsoft.com/office/drawing/2014/main" id="{A3952EA3-61F3-444D-8163-71D19E530BB1}"/>
+              </a:ext>
+            </a:extLst>
+          </p:cNvPr>
+          <p:cNvSpPr>
+            <a:spLocks noGrp="1"/>
+          </p:cNvSpPr>
+          <p:nvPr/>
+        </p:nvSpPr>
+        <p:spPr>
+          <a:xfrm>
+            <a:off x="1133475" y="3876675"/>
+            <a:ext cx="6343650" cy="409575"/>
+          </a:xfrm>
+          <a:prstGeom prst="rect">
+            <a:avLst/>
+          </a:prstGeom>
+          <a:noFill/>
+          <a:ln w="0">
+            <a:noFill/>
+          </a:ln>
+        </p:spPr>
+        <p:txBody>
+          <a:bodyPr>
+            <a:noAutofit/>
+          </a:bodyPr>
+          <a:lstStyle/>
+          <a:p>
+            <a:pPr>
+              <a:defRPr sz="2100" b="1">
+                <a:solidFill>
+                  <a:srgbClr val="FEF9E4"/>
+                </a:solidFill>
+                <a:latin typeface="Apfel Grotezk"/>
+                <a:ea typeface="Apfel Grotezk"/>
+                <a:cs typeface="Apfel Grotezk"/>
+              </a:defRPr>
+            </a:pPr>
+            <a:r>
+              <a:rPr sz="2100" b="1">
+                <a:solidFill>
+                  <a:srgbClr val="FEF9E4"/>
+                </a:solidFill>
+                <a:latin typeface="Apfel Grotezk"/>
+                <a:ea typeface="Apfel Grotezk"/>
+                <a:cs typeface="Apfel Grotezk"/>
+              </a:rPr>
+              <a:t>Explore the structure</a:t>
+            </a:r>
+          </a:p>
+        </p:txBody>
+      </p:sp>
+      <p:sp>
+        <p:nvSpPr>
+          <p:cNvPr id="17" name="">
+            <a:extLst>
+              <a:ext uri="{FF2B5EF4-FFF2-40B4-BE49-F238E27FC236}">
+                <a16:creationId xmlns:a16="http://schemas.microsoft.com/office/drawing/2014/main" id="{D32C33A2-9249-45BE-9C6F-9508BD34338D}"/>
+              </a:ext>
+            </a:extLst>
+          </p:cNvPr>
+          <p:cNvSpPr>
+            <a:spLocks noGrp="1"/>
+          </p:cNvSpPr>
+          <p:nvPr/>
+        </p:nvSpPr>
+        <p:spPr>
+          <a:xfrm>
+            <a:off x="1133475" y="4276725"/>
+            <a:ext cx="6276975" cy="628650"/>
+          </a:xfrm>
+          <a:prstGeom prst="rect">
+            <a:avLst/>
+          </a:prstGeom>
+          <a:noFill/>
+          <a:ln w="0">
+            <a:noFill/>
+          </a:ln>
+        </p:spPr>
+        <p:txBody>
+          <a:bodyPr>
+            <a:noAutofit/>
+          </a:bodyPr>
+          <a:lstStyle/>
+          <a:p>
+            <a:pPr>
+              <a:defRPr sz="1800" b="0">
+                <a:solidFill>
+                  <a:srgbClr val="FEF9E4"/>
+                </a:solidFill>
+                <a:latin typeface="Apfel Grotezk"/>
+                <a:ea typeface="Apfel Grotezk"/>
+                <a:cs typeface="Apfel Grotezk"/>
+              </a:defRPr>
+            </a:pPr>
+            <a:r>
+              <a:rPr sz="1800" b="0">
+                <a:solidFill>
+                  <a:srgbClr val="FEF9E4"/>
+                </a:solidFill>
+                <a:latin typeface="Apfel Grotezk"/>
+                <a:ea typeface="Apfel Grotezk"/>
+                <a:cs typeface="Apfel Grotezk"/>
+              </a:rPr>
+              <a:t>Hide a layer, restore it, then find a street label.</a:t>
+            </a:r>
+          </a:p>
+        </p:txBody>
+      </p:sp>
+      <p:sp>
+        <p:nvSpPr>
+          <p:cNvPr id="18" name="">
+            <a:extLst>
+              <a:ext uri="{FF2B5EF4-FFF2-40B4-BE49-F238E27FC236}">
+                <a16:creationId xmlns:a16="http://schemas.microsoft.com/office/drawing/2014/main" id="{5955203C-20CD-4A19-ACD7-AF081B69595D}"/>
+              </a:ext>
+            </a:extLst>
+          </p:cNvPr>
+          <p:cNvSpPr>
+            <a:spLocks noGrp="1"/>
+          </p:cNvSpPr>
+          <p:nvPr/>
+        </p:nvSpPr>
+        <p:spPr>
+          <a:xfrm>
+            <a:off x="457200" y="4781550"/>
+            <a:ext cx="619125" cy="476250"/>
+          </a:xfrm>
+          <a:prstGeom prst="rect">
+            <a:avLst/>
+          </a:prstGeom>
+          <a:noFill/>
+          <a:ln w="0">
+            <a:noFill/>
+          </a:ln>
+        </p:spPr>
+        <p:txBody>
+          <a:bodyPr>
+            <a:noAutofit/>
+          </a:bodyPr>
+          <a:lstStyle/>
+          <a:p>
+            <a:pPr>
+              <a:defRPr sz="2550" b="0">
+                <a:solidFill>
+                  <a:srgbClr val="FEF9E4"/>
+                </a:solidFill>
+                <a:latin typeface="Mayonnaise Black"/>
+                <a:ea typeface="Mayonnaise Black"/>
+                <a:cs typeface="Mayonnaise Black"/>
+              </a:defRPr>
+            </a:pPr>
+            <a:r>
+              <a:rPr sz="2550" b="0">
+                <a:solidFill>
+                  <a:srgbClr val="FEF9E4"/>
+                </a:solidFill>
+                <a:latin typeface="Mayonnaise Black"/>
+                <a:ea typeface="Mayonnaise Black"/>
+                <a:cs typeface="Mayonnaise Black"/>
+              </a:rPr>
+              <a:t>04</a:t>
+            </a:r>
+          </a:p>
+        </p:txBody>
+      </p:sp>
+      <p:sp>
+        <p:nvSpPr>
+          <p:cNvPr id="19" name="">
+            <a:extLst>
+              <a:ext uri="{FF2B5EF4-FFF2-40B4-BE49-F238E27FC236}">
+                <a16:creationId xmlns:a16="http://schemas.microsoft.com/office/drawing/2014/main" id="{403F2497-7E87-49C5-8E17-1357CF7F2789}"/>
+              </a:ext>
+            </a:extLst>
+          </p:cNvPr>
+          <p:cNvSpPr>
+            <a:spLocks noGrp="1"/>
+          </p:cNvSpPr>
+          <p:nvPr/>
+        </p:nvSpPr>
+        <p:spPr>
+          <a:xfrm>
+            <a:off x="1133475" y="4781550"/>
+            <a:ext cx="6343650" cy="409575"/>
+          </a:xfrm>
+          <a:prstGeom prst="rect">
+            <a:avLst/>
+          </a:prstGeom>
+          <a:noFill/>
+          <a:ln w="0">
+            <a:noFill/>
+          </a:ln>
+        </p:spPr>
+        <p:txBody>
+          <a:bodyPr>
+            <a:noAutofit/>
+          </a:bodyPr>
+          <a:lstStyle/>
+          <a:p>
+            <a:pPr>
+              <a:defRPr sz="2100" b="1">
+                <a:solidFill>
+                  <a:srgbClr val="FEF9E4"/>
+                </a:solidFill>
+                <a:latin typeface="Apfel Grotezk"/>
+                <a:ea typeface="Apfel Grotezk"/>
+                <a:cs typeface="Apfel Grotezk"/>
+              </a:defRPr>
+            </a:pPr>
+            <a:r>
+              <a:rPr sz="2100" b="1">
+                <a:solidFill>
+                  <a:srgbClr val="FEF9E4"/>
                 </a:solidFill>
                 <a:latin typeface="Apfel Grotezk"/>
                 <a:ea typeface="Apfel Grotezk"/>
@@ -3094,51 +3432,51 @@
       </p:sp>
       <p:sp>
         <p:nvSpPr>
-          <p:cNvPr id="14" name="">
-            <a:extLst>
-              <a:ext uri="{FF2B5EF4-FFF2-40B4-BE49-F238E27FC236}">
-                <a16:creationId xmlns:a16="http://schemas.microsoft.com/office/drawing/2014/main" id="{9CBD4A29-7B46-4782-BE6B-DBE9C822AEDE}"/>
-              </a:ext>
-            </a:extLst>
-          </p:cNvPr>
-          <p:cNvSpPr>
-            <a:spLocks noGrp="1"/>
-          </p:cNvSpPr>
-          <p:nvPr/>
-        </p:nvSpPr>
-        <p:spPr>
-          <a:xfrm>
-            <a:off x="1257300" y="4848225"/>
-            <a:ext cx="10248900" cy="638175"/>
-          </a:xfrm>
-          <a:prstGeom prst="rect">
-            <a:avLst/>
-          </a:prstGeom>
-          <a:noFill/>
-          <a:ln w="0">
-            <a:noFill/>
-          </a:ln>
-        </p:spPr>
-        <p:txBody>
-          <a:bodyPr>
-            <a:noAutofit/>
-          </a:bodyPr>
-          <a:lstStyle/>
-          <a:p>
-            <a:pPr>
-              <a:defRPr sz="1950" b="0">
-                <a:solidFill>
-                  <a:srgbClr val="18180F"/>
-                </a:solidFill>
-                <a:latin typeface="Apfel Grotezk"/>
-                <a:ea typeface="Apfel Grotezk"/>
-                <a:cs typeface="Apfel Grotezk"/>
-              </a:defRPr>
-            </a:pPr>
-            <a:r>
-              <a:rPr sz="1950" b="0">
-                <a:solidFill>
-                  <a:srgbClr val="18180F"/>
+          <p:cNvPr id="20" name="">
+            <a:extLst>
+              <a:ext uri="{FF2B5EF4-FFF2-40B4-BE49-F238E27FC236}">
+                <a16:creationId xmlns:a16="http://schemas.microsoft.com/office/drawing/2014/main" id="{F12E72D4-B250-4BCE-A682-75569286C400}"/>
+              </a:ext>
+            </a:extLst>
+          </p:cNvPr>
+          <p:cNvSpPr>
+            <a:spLocks noGrp="1"/>
+          </p:cNvSpPr>
+          <p:nvPr/>
+        </p:nvSpPr>
+        <p:spPr>
+          <a:xfrm>
+            <a:off x="1133475" y="5181600"/>
+            <a:ext cx="6276975" cy="628650"/>
+          </a:xfrm>
+          <a:prstGeom prst="rect">
+            <a:avLst/>
+          </a:prstGeom>
+          <a:noFill/>
+          <a:ln w="0">
+            <a:noFill/>
+          </a:ln>
+        </p:spPr>
+        <p:txBody>
+          <a:bodyPr>
+            <a:noAutofit/>
+          </a:bodyPr>
+          <a:lstStyle/>
+          <a:p>
+            <a:pPr>
+              <a:defRPr sz="1800" b="0">
+                <a:solidFill>
+                  <a:srgbClr val="FEF9E4"/>
+                </a:solidFill>
+                <a:latin typeface="Apfel Grotezk"/>
+                <a:ea typeface="Apfel Grotezk"/>
+                <a:cs typeface="Apfel Grotezk"/>
+              </a:defRPr>
+            </a:pPr>
+            <a:r>
+              <a:rPr sz="1800" b="0">
+                <a:solidFill>
+                  <a:srgbClr val="FEF9E4"/>
                 </a:solidFill>
                 <a:latin typeface="Apfel Grotezk"/>
                 <a:ea typeface="Apfel Grotezk"/>
@@ -3151,28 +3489,497 @@
       </p:sp>
       <p:sp>
         <p:nvSpPr>
-          <p:cNvPr id="15" name="">
-            <a:extLst>
-              <a:ext uri="{FF2B5EF4-FFF2-40B4-BE49-F238E27FC236}">
-                <a16:creationId xmlns:a16="http://schemas.microsoft.com/office/drawing/2014/main" id="{3FB41CC5-BCC7-4E4C-BC5E-5E9520197C09}"/>
-              </a:ext>
-            </a:extLst>
-          </p:cNvPr>
-          <p:cNvSpPr>
-            <a:spLocks noGrp="1"/>
-          </p:cNvSpPr>
-          <p:nvPr/>
-        </p:nvSpPr>
-        <p:spPr>
-          <a:xfrm>
-            <a:off x="457200" y="5524500"/>
-            <a:ext cx="11277600" cy="628650"/>
+          <p:cNvPr id="21" name="">
+            <a:extLst>
+              <a:ext uri="{FF2B5EF4-FFF2-40B4-BE49-F238E27FC236}">
+                <a16:creationId xmlns:a16="http://schemas.microsoft.com/office/drawing/2014/main" id="{7BA8C781-9267-4C58-A5B6-E616A48DFA0D}"/>
+              </a:ext>
+            </a:extLst>
+          </p:cNvPr>
+          <p:cNvSpPr>
+            <a:spLocks noGrp="1"/>
+          </p:cNvSpPr>
+          <p:nvPr/>
+        </p:nvSpPr>
+        <p:spPr>
+          <a:xfrm>
+            <a:off x="7962900" y="2028825"/>
+            <a:ext cx="3771900" cy="381000"/>
+          </a:xfrm>
+          <a:prstGeom prst="rect">
+            <a:avLst/>
+          </a:prstGeom>
+          <a:noFill/>
+          <a:ln w="0">
+            <a:noFill/>
+          </a:ln>
+        </p:spPr>
+        <p:txBody>
+          <a:bodyPr>
+            <a:noAutofit/>
+          </a:bodyPr>
+          <a:lstStyle/>
+          <a:p>
+            <a:pPr>
+              <a:defRPr sz="1950" b="1">
+                <a:solidFill>
+                  <a:srgbClr val="FEF9E4"/>
+                </a:solidFill>
+                <a:latin typeface="Apfel Grotezk"/>
+                <a:ea typeface="Apfel Grotezk"/>
+                <a:cs typeface="Apfel Grotezk"/>
+              </a:defRPr>
+            </a:pPr>
+            <a:r>
+              <a:rPr sz="1950" b="1">
+                <a:solidFill>
+                  <a:srgbClr val="FEF9E4"/>
+                </a:solidFill>
+                <a:latin typeface="Apfel Grotezk"/>
+                <a:ea typeface="Apfel Grotezk"/>
+                <a:cs typeface="Apfel Grotezk"/>
+              </a:rPr>
+              <a:t>Export taking a while?</a:t>
+            </a:r>
+          </a:p>
+        </p:txBody>
+      </p:sp>
+      <p:sp>
+        <p:nvSpPr>
+          <p:cNvPr id="22" name="">
+            <a:extLst>
+              <a:ext uri="{FF2B5EF4-FFF2-40B4-BE49-F238E27FC236}">
+                <a16:creationId xmlns:a16="http://schemas.microsoft.com/office/drawing/2014/main" id="{0FE347F3-C16F-4A11-A9DE-3061F5DBF14E}"/>
+              </a:ext>
+            </a:extLst>
+          </p:cNvPr>
+          <p:cNvSpPr>
+            <a:spLocks noGrp="1"/>
+          </p:cNvSpPr>
+          <p:nvPr/>
+        </p:nvSpPr>
+        <p:spPr>
+          <a:xfrm>
+            <a:off x="7962900" y="2419350"/>
+            <a:ext cx="3771900" cy="685800"/>
+          </a:xfrm>
+          <a:prstGeom prst="rect">
+            <a:avLst/>
+          </a:prstGeom>
+          <a:noFill/>
+          <a:ln w="0">
+            <a:noFill/>
+          </a:ln>
+        </p:spPr>
+        <p:txBody>
+          <a:bodyPr>
+            <a:noAutofit/>
+          </a:bodyPr>
+          <a:lstStyle/>
+          <a:p>
+            <a:pPr>
+              <a:defRPr sz="1725" b="0">
+                <a:solidFill>
+                  <a:srgbClr val="FEF9E4"/>
+                </a:solidFill>
+                <a:latin typeface="Apfel Grotezk"/>
+                <a:ea typeface="Apfel Grotezk"/>
+                <a:cs typeface="Apfel Grotezk"/>
+              </a:defRPr>
+            </a:pPr>
+            <a:r>
+              <a:rPr sz="1725" b="0">
+                <a:solidFill>
+                  <a:srgbClr val="FEF9E4"/>
+                </a:solidFill>
+                <a:latin typeface="Apfel Grotezk"/>
+                <a:ea typeface="Apfel Grotezk"/>
+                <a:cs typeface="Apfel Grotezk"/>
+              </a:rPr>
+              <a:t>Watch progress. Try a smaller area</a:t>
+            </a:r>
+          </a:p>
+          <a:p>
+            <a:pPr>
+              <a:defRPr sz="1725" b="0">
+                <a:solidFill>
+                  <a:srgbClr val="FEF9E4"/>
+                </a:solidFill>
+                <a:latin typeface="Apfel Grotezk"/>
+                <a:ea typeface="Apfel Grotezk"/>
+                <a:cs typeface="Apfel Grotezk"/>
+              </a:defRPr>
+            </a:pPr>
+            <a:r>
+              <a:rPr sz="1725" b="0">
+                <a:solidFill>
+                  <a:srgbClr val="FEF9E4"/>
+                </a:solidFill>
+                <a:latin typeface="Apfel Grotezk"/>
+                <a:ea typeface="Apfel Grotezk"/>
+                <a:cs typeface="Apfel Grotezk"/>
+              </a:rPr>
+              <a:t>for your next export.</a:t>
+            </a:r>
+          </a:p>
+        </p:txBody>
+      </p:sp>
+      <p:sp>
+        <p:nvSpPr>
+          <p:cNvPr id="23" name="">
+            <a:extLst>
+              <a:ext uri="{FF2B5EF4-FFF2-40B4-BE49-F238E27FC236}">
+                <a16:creationId xmlns:a16="http://schemas.microsoft.com/office/drawing/2014/main" id="{0DEFABD4-67B8-4E9D-99CF-0634273135B6}"/>
+              </a:ext>
+            </a:extLst>
+          </p:cNvPr>
+          <p:cNvSpPr>
+            <a:spLocks noGrp="1"/>
+          </p:cNvSpPr>
+          <p:nvPr/>
+        </p:nvSpPr>
+        <p:spPr>
+          <a:xfrm>
+            <a:off x="7962900" y="3181350"/>
+            <a:ext cx="3771900" cy="381000"/>
+          </a:xfrm>
+          <a:prstGeom prst="rect">
+            <a:avLst/>
+          </a:prstGeom>
+          <a:noFill/>
+          <a:ln w="0">
+            <a:noFill/>
+          </a:ln>
+        </p:spPr>
+        <p:txBody>
+          <a:bodyPr>
+            <a:noAutofit/>
+          </a:bodyPr>
+          <a:lstStyle/>
+          <a:p>
+            <a:pPr>
+              <a:defRPr sz="1950" b="1">
+                <a:solidFill>
+                  <a:srgbClr val="FEF9E4"/>
+                </a:solidFill>
+                <a:latin typeface="Apfel Grotezk"/>
+                <a:ea typeface="Apfel Grotezk"/>
+                <a:cs typeface="Apfel Grotezk"/>
+              </a:defRPr>
+            </a:pPr>
+            <a:r>
+              <a:rPr sz="1950" b="1">
+                <a:solidFill>
+                  <a:srgbClr val="FEF9E4"/>
+                </a:solidFill>
+                <a:latin typeface="Apfel Grotezk"/>
+                <a:ea typeface="Apfel Grotezk"/>
+                <a:cs typeface="Apfel Grotezk"/>
+              </a:rPr>
+              <a:t>Practise with the Gent SVG:</a:t>
+            </a:r>
+          </a:p>
+        </p:txBody>
+      </p:sp>
+      <p:sp>
+        <p:nvSpPr>
+          <p:cNvPr id="24" name="">
+            <a:extLst>
+              <a:ext uri="{FF2B5EF4-FFF2-40B4-BE49-F238E27FC236}">
+                <a16:creationId xmlns:a16="http://schemas.microsoft.com/office/drawing/2014/main" id="{484B4AAB-8B53-4AF1-B88B-BD213B1B0F9D}"/>
+              </a:ext>
+            </a:extLst>
+          </p:cNvPr>
+          <p:cNvSpPr>
+            <a:spLocks noGrp="1"/>
+          </p:cNvSpPr>
+          <p:nvPr/>
+        </p:nvSpPr>
+        <p:spPr>
+          <a:xfrm>
+            <a:off x="7962900" y="3562350"/>
+            <a:ext cx="3771900" cy="381000"/>
+          </a:xfrm>
+          <a:prstGeom prst="rect">
+            <a:avLst/>
+          </a:prstGeom>
+          <a:noFill/>
+          <a:ln w="0">
+            <a:noFill/>
+          </a:ln>
+        </p:spPr>
+        <p:txBody>
+          <a:bodyPr>
+            <a:noAutofit/>
+          </a:bodyPr>
+          <a:lstStyle/>
+          <a:p>
+            <a:pPr>
+              <a:defRPr sz="2025" b="1">
+                <a:solidFill>
+                  <a:srgbClr val="FEF9E4"/>
+                </a:solidFill>
+                <a:latin typeface="Apfel Grotezk"/>
+                <a:ea typeface="Apfel Grotezk"/>
+                <a:cs typeface="Apfel Grotezk"/>
+              </a:defRPr>
+            </a:pPr>
+            <a:r>
+              <a:rPr sz="2025" b="1" u="sng">
+                <a:solidFill>
+                  <a:srgbClr val="FEF9E4"/>
+                </a:solidFill>
+                <a:latin typeface="Apfel Grotezk"/>
+                <a:ea typeface="Apfel Grotezk"/>
+                <a:cs typeface="Apfel Grotezk"/>
+                <a:hlinkClick r:id="rIdDemo"/>
+              </a:rPr>
+              <a:t>coen.at/ghent.svg</a:t>
+            </a:r>
+          </a:p>
+        </p:txBody>
+      </p:sp>
+      <p:sp>
+        <p:nvSpPr>
+          <p:cNvPr id="25" name="">
+            <a:extLst>
+              <a:ext uri="{FF2B5EF4-FFF2-40B4-BE49-F238E27FC236}">
+                <a16:creationId xmlns:a16="http://schemas.microsoft.com/office/drawing/2014/main" id="{FB2F8BDB-D49C-4BE8-8A33-498F18F24320}"/>
+              </a:ext>
+            </a:extLst>
+          </p:cNvPr>
+          <p:cNvSpPr>
+            <a:spLocks noGrp="1"/>
+          </p:cNvSpPr>
+          <p:nvPr/>
+        </p:nvSpPr>
+        <p:spPr>
+          <a:xfrm>
+            <a:off x="7962900" y="4124325"/>
+            <a:ext cx="3771900" cy="381000"/>
+          </a:xfrm>
+          <a:prstGeom prst="rect">
+            <a:avLst/>
+          </a:prstGeom>
+          <a:noFill/>
+          <a:ln w="0">
+            <a:noFill/>
+          </a:ln>
+        </p:spPr>
+        <p:txBody>
+          <a:bodyPr>
+            <a:noAutofit/>
+          </a:bodyPr>
+          <a:lstStyle/>
+          <a:p>
+            <a:pPr>
+              <a:defRPr sz="1950" b="1">
+                <a:solidFill>
+                  <a:srgbClr val="FEF9E4"/>
+                </a:solidFill>
+                <a:latin typeface="Apfel Grotezk"/>
+                <a:ea typeface="Apfel Grotezk"/>
+                <a:cs typeface="Apfel Grotezk"/>
+              </a:defRPr>
+            </a:pPr>
+            <a:r>
+              <a:rPr sz="1950" b="1">
+                <a:solidFill>
+                  <a:srgbClr val="FEF9E4"/>
+                </a:solidFill>
+                <a:latin typeface="Apfel Grotezk"/>
+                <a:ea typeface="Apfel Grotezk"/>
+                <a:cs typeface="Apfel Grotezk"/>
+              </a:rPr>
+              <a:t>File looks unexpected?</a:t>
+            </a:r>
+          </a:p>
+        </p:txBody>
+      </p:sp>
+      <p:sp>
+        <p:nvSpPr>
+          <p:cNvPr id="26" name="">
+            <a:extLst>
+              <a:ext uri="{FF2B5EF4-FFF2-40B4-BE49-F238E27FC236}">
+                <a16:creationId xmlns:a16="http://schemas.microsoft.com/office/drawing/2014/main" id="{E263B122-C310-4A66-814C-3589E04AC66D}"/>
+              </a:ext>
+            </a:extLst>
+          </p:cNvPr>
+          <p:cNvSpPr>
+            <a:spLocks noGrp="1"/>
+          </p:cNvSpPr>
+          <p:nvPr/>
+        </p:nvSpPr>
+        <p:spPr>
+          <a:xfrm>
+            <a:off x="7962900" y="4514850"/>
+            <a:ext cx="3771900" cy="666750"/>
+          </a:xfrm>
+          <a:prstGeom prst="rect">
+            <a:avLst/>
+          </a:prstGeom>
+          <a:noFill/>
+          <a:ln w="0">
+            <a:noFill/>
+          </a:ln>
+        </p:spPr>
+        <p:txBody>
+          <a:bodyPr>
+            <a:noAutofit/>
+          </a:bodyPr>
+          <a:lstStyle/>
+          <a:p>
+            <a:pPr>
+              <a:defRPr sz="1725" b="0">
+                <a:solidFill>
+                  <a:srgbClr val="FEF9E4"/>
+                </a:solidFill>
+                <a:latin typeface="Apfel Grotezk"/>
+                <a:ea typeface="Apfel Grotezk"/>
+                <a:cs typeface="Apfel Grotezk"/>
+              </a:defRPr>
+            </a:pPr>
+            <a:r>
+              <a:rPr sz="1725" b="0">
+                <a:solidFill>
+                  <a:srgbClr val="FEF9E4"/>
+                </a:solidFill>
+                <a:latin typeface="Apfel Grotezk"/>
+                <a:ea typeface="Apfel Grotezk"/>
+                <a:cs typeface="Apfel Grotezk"/>
+              </a:rPr>
+              <a:t>Check SVG format, fonts and</a:t>
+            </a:r>
+          </a:p>
+          <a:p>
+            <a:pPr>
+              <a:defRPr sz="1725" b="0">
+                <a:solidFill>
+                  <a:srgbClr val="FEF9E4"/>
+                </a:solidFill>
+                <a:latin typeface="Apfel Grotezk"/>
+                <a:ea typeface="Apfel Grotezk"/>
+                <a:cs typeface="Apfel Grotezk"/>
+              </a:defRPr>
+            </a:pPr>
+            <a:r>
+              <a:rPr sz="1725" b="0">
+                <a:solidFill>
+                  <a:srgbClr val="FEF9E4"/>
+                </a:solidFill>
+                <a:latin typeface="Apfel Grotezk"/>
+                <a:ea typeface="Apfel Grotezk"/>
+                <a:cs typeface="Apfel Grotezk"/>
+              </a:rPr>
+              <a:t>layer visibility.</a:t>
+            </a:r>
+          </a:p>
+        </p:txBody>
+      </p:sp>
+      <p:sp>
+        <p:nvSpPr>
+          <p:cNvPr id="27" name="">
+            <a:extLst>
+              <a:ext uri="{FF2B5EF4-FFF2-40B4-BE49-F238E27FC236}">
+                <a16:creationId xmlns:a16="http://schemas.microsoft.com/office/drawing/2014/main" id="{11812290-469F-4702-947F-9FBCB0D7436D}"/>
+              </a:ext>
+            </a:extLst>
+          </p:cNvPr>
+          <p:cNvSpPr>
+            <a:spLocks noGrp="1"/>
+          </p:cNvSpPr>
+          <p:nvPr/>
+        </p:nvSpPr>
+        <p:spPr>
+          <a:xfrm>
+            <a:off x="7962900" y="5200650"/>
+            <a:ext cx="3771900" cy="552450"/>
+          </a:xfrm>
+          <a:prstGeom prst="rect">
+            <a:avLst/>
+          </a:prstGeom>
+          <a:noFill/>
+          <a:ln w="0">
+            <a:noFill/>
+          </a:ln>
+        </p:spPr>
+        <p:txBody>
+          <a:bodyPr>
+            <a:noAutofit/>
+          </a:bodyPr>
+          <a:lstStyle/>
+          <a:p>
+            <a:pPr>
+              <a:defRPr sz="1575" b="0">
+                <a:solidFill>
+                  <a:srgbClr val="FEF9E4"/>
+                </a:solidFill>
+                <a:latin typeface="Apfel Grotezk"/>
+                <a:ea typeface="Apfel Grotezk"/>
+                <a:cs typeface="Apfel Grotezk"/>
+              </a:defRPr>
+            </a:pPr>
+            <a:r>
+              <a:rPr sz="1575" b="0">
+                <a:solidFill>
+                  <a:srgbClr val="FEF9E4"/>
+                </a:solidFill>
+                <a:latin typeface="Apfel Grotezk"/>
+                <a:ea typeface="Apfel Grotezk"/>
+                <a:cs typeface="Apfel Grotezk"/>
+              </a:rPr>
+              <a:t>Bug report: city + selected area</a:t>
+            </a:r>
+          </a:p>
+          <a:p>
+            <a:pPr>
+              <a:defRPr sz="1575" b="0">
+                <a:solidFill>
+                  <a:srgbClr val="FEF9E4"/>
+                </a:solidFill>
+                <a:latin typeface="Apfel Grotezk"/>
+                <a:ea typeface="Apfel Grotezk"/>
+                <a:cs typeface="Apfel Grotezk"/>
+              </a:defRPr>
+            </a:pPr>
+            <a:r>
+              <a:rPr sz="1575" b="0">
+                <a:solidFill>
+                  <a:srgbClr val="FEF9E4"/>
+                </a:solidFill>
+                <a:latin typeface="Apfel Grotezk"/>
+                <a:ea typeface="Apfel Grotezk"/>
+                <a:cs typeface="Apfel Grotezk"/>
+              </a:rPr>
+              <a:t>+ editor + what you expected.</a:t>
+            </a:r>
+          </a:p>
+        </p:txBody>
+      </p:sp>
+      <p:sp>
+        <p:nvSpPr>
+          <p:cNvPr id="28" name="">
+            <a:extLst>
+              <a:ext uri="{FF2B5EF4-FFF2-40B4-BE49-F238E27FC236}">
+                <a16:creationId xmlns:a16="http://schemas.microsoft.com/office/drawing/2014/main" id="{CB16CD9F-60A2-47CE-9104-80F737F48B37}"/>
+              </a:ext>
+            </a:extLst>
+          </p:cNvPr>
+          <p:cNvSpPr>
+            <a:spLocks noGrp="1"/>
+          </p:cNvSpPr>
+          <p:nvPr/>
+        </p:nvSpPr>
+        <p:spPr>
+          <a:xfrm>
+            <a:off x="457200" y="5838825"/>
+            <a:ext cx="11277600" cy="428625"/>
           </a:xfrm>
           <a:prstGeom prst="rect">
             <a:avLst/>
           </a:prstGeom>
           <a:solidFill>
-            <a:srgbClr val="7ECAB6"/>
+            <a:srgbClr val="FEF9E4"/>
           </a:solidFill>
           <a:ln w="0">
             <a:noFill/>
@@ -3181,115 +3988,57 @@
       </p:sp>
       <p:sp>
         <p:nvSpPr>
-          <p:cNvPr id="16" name="">
-            <a:extLst>
-              <a:ext uri="{FF2B5EF4-FFF2-40B4-BE49-F238E27FC236}">
-                <a16:creationId xmlns:a16="http://schemas.microsoft.com/office/drawing/2014/main" id="{414BB8E9-E2CD-4B85-8092-AA6F14EF67B8}"/>
-              </a:ext>
-            </a:extLst>
-          </p:cNvPr>
-          <p:cNvSpPr>
-            <a:spLocks noGrp="1"/>
-          </p:cNvSpPr>
-          <p:nvPr/>
-        </p:nvSpPr>
-        <p:spPr>
-          <a:xfrm>
-            <a:off x="619125" y="5638800"/>
-            <a:ext cx="6953250" cy="419100"/>
-          </a:xfrm>
-          <a:prstGeom prst="rect">
-            <a:avLst/>
-          </a:prstGeom>
-          <a:noFill/>
-          <a:ln w="0">
-            <a:noFill/>
-          </a:ln>
-        </p:spPr>
-        <p:txBody>
-          <a:bodyPr>
-            <a:noAutofit/>
-          </a:bodyPr>
-          <a:lstStyle/>
-          <a:p>
-            <a:pPr>
-              <a:defRPr sz="2025" b="1">
-                <a:solidFill>
-                  <a:srgbClr val="18180F"/>
-                </a:solidFill>
-                <a:latin typeface="Apfel Grotezk"/>
-                <a:ea typeface="Apfel Grotezk"/>
-                <a:cs typeface="Apfel Grotezk"/>
-              </a:defRPr>
-            </a:pPr>
-            <a:r>
-              <a:rPr sz="2025" b="1">
-                <a:solidFill>
-                  <a:srgbClr val="18180F"/>
-                </a:solidFill>
-                <a:latin typeface="Apfel Grotezk"/>
-                <a:ea typeface="Apfel Grotezk"/>
-                <a:cs typeface="Apfel Grotezk"/>
-              </a:rPr>
-              <a:t>Export still running? Use the demo:</a:t>
-            </a:r>
-          </a:p>
-        </p:txBody>
-      </p:sp>
-      <p:sp>
-        <p:nvSpPr>
-          <p:cNvPr id="17" name="">
-            <a:extLst>
-              <a:ext uri="{FF2B5EF4-FFF2-40B4-BE49-F238E27FC236}">
-                <a16:creationId xmlns:a16="http://schemas.microsoft.com/office/drawing/2014/main" id="{4FFE1E4C-8E2A-4E99-A899-7B22BF6E9FE4}"/>
-              </a:ext>
-            </a:extLst>
-          </p:cNvPr>
-          <p:cNvSpPr>
-            <a:spLocks noGrp="1"/>
-          </p:cNvSpPr>
-          <p:nvPr/>
-        </p:nvSpPr>
-        <p:spPr>
-          <a:xfrm>
-            <a:off x="8143875" y="5638800"/>
-            <a:ext cx="3333750" cy="419100"/>
-          </a:xfrm>
-          <a:prstGeom prst="rect">
-            <a:avLst/>
-          </a:prstGeom>
-          <a:noFill/>
-          <a:ln w="0">
-            <a:noFill/>
-          </a:ln>
-        </p:spPr>
-        <p:txBody>
-          <a:bodyPr>
-            <a:noAutofit/>
-          </a:bodyPr>
-          <a:lstStyle/>
-          <a:p>
-            <a:pPr>
-              <a:defRPr sz="2025" b="1">
-                <a:solidFill>
-                  <a:srgbClr val="18180F"/>
-                </a:solidFill>
-                <a:latin typeface="Apfel Grotezk"/>
-                <a:ea typeface="Apfel Grotezk"/>
-                <a:cs typeface="Apfel Grotezk"/>
-              </a:defRPr>
-            </a:pPr>
-            <a:r>
-              <a:rPr sz="2025" b="1" u="sng">
-                <a:solidFill>
-                  <a:srgbClr val="18180F"/>
-                </a:solidFill>
-                <a:latin typeface="Apfel Grotezk"/>
-                <a:ea typeface="Apfel Grotezk"/>
-                <a:cs typeface="Apfel Grotezk"/>
-                <a:hlinkClick r:id="rIdDemo"/>
-              </a:rPr>
-              <a:t>coen.at/ghent.svg</a:t>
+          <p:cNvPr id="29" name="">
+            <a:extLst>
+              <a:ext uri="{FF2B5EF4-FFF2-40B4-BE49-F238E27FC236}">
+                <a16:creationId xmlns:a16="http://schemas.microsoft.com/office/drawing/2014/main" id="{352BC211-499B-419D-A6C6-9C74B01A0E07}"/>
+              </a:ext>
+            </a:extLst>
+          </p:cNvPr>
+          <p:cNvSpPr>
+            <a:spLocks noGrp="1"/>
+          </p:cNvSpPr>
+          <p:nvPr/>
+        </p:nvSpPr>
+        <p:spPr>
+          <a:xfrm>
+            <a:off x="600075" y="5876925"/>
+            <a:ext cx="10915650" cy="371475"/>
+          </a:xfrm>
+          <a:prstGeom prst="rect">
+            <a:avLst/>
+          </a:prstGeom>
+          <a:noFill/>
+          <a:ln w="0">
+            <a:noFill/>
+          </a:ln>
+        </p:spPr>
+        <p:txBody>
+          <a:bodyPr>
+            <a:noAutofit/>
+          </a:bodyPr>
+          <a:lstStyle/>
+          <a:p>
+            <a:pPr>
+              <a:defRPr sz="1950" b="1">
+                <a:solidFill>
+                  <a:srgbClr val="18180F"/>
+                </a:solidFill>
+                <a:latin typeface="Apfel Grotezk"/>
+                <a:ea typeface="Apfel Grotezk"/>
+                <a:cs typeface="Apfel Grotezk"/>
+              </a:defRPr>
+            </a:pPr>
+            <a:r>
+              <a:rPr sz="1950" b="1">
+                <a:solidFill>
+                  <a:srgbClr val="18180F"/>
+                </a:solidFill>
+                <a:latin typeface="Apfel Grotezk"/>
+                <a:ea typeface="Apfel Grotezk"/>
+                <a:cs typeface="Apfel Grotezk"/>
+              </a:rPr>
+              <a:t>Done early? Compare the result with a place you know well.</a:t>
             </a:r>
           </a:p>
         </p:txBody>
@@ -3297,7 +4046,7 @@
     </p:spTree>
     <p:extLst>
       <p:ext uri="{BB962C8B-B14F-4D97-AF65-F5344CB8AC3E}">
-        <p14:creationId xmlns:p14="http://schemas.microsoft.com/office/powerpoint/2010/main" val="950624055"/>
+        <p14:creationId xmlns:p14="http://schemas.microsoft.com/office/powerpoint/2010/main" val="1668963156"/>
       </p:ext>
     </p:extLst>
   </p:cSld>

</xml_diff>

<commit_message>
Improve interactive map and persistent export fetching
</commit_message>
<xml_diff>
--- a/presentations/mapexport-workshop-merged.pptx
+++ b/presentations/mapexport-workshop-merged.pptx
@@ -424,16 +424,38 @@
           <a:lstStyle/>
           <a:p>
             <a:r>
-              <a:t>Keep this slide on screen throughout the hands-on exercise. Allow about 20 minutes. Participants can work individually or in pairs. Start with a small central area and choose the SVG format for the editor. Use File &gt; Open and keep the original download. Select only the City blocks paths before changing Fill. Keep roads and water unchanged. Hide and restore a layer, then find a street label. Save a separate working copy and note one concrete observation for the discussion. Done early? Compare the map with a place you know well. If an export is delayed, use https://coen.at/ghent.svg (local backup: presentations/assets/ghent-demo.svg). Watch the progress message and try a smaller area next time. If the file looks unexpected, check SVG format, fonts and layer visibility. Useful bug reports include city, area, editor and expected result.</a:t>
-            </a:r>
-          </a:p>
-          <a:p>
-            <a:endParaRPr/>
-          </a:p>
-          <a:p>
-            <a:r>
-              <a:t>Sources: live https://coen.at/mapexport/ inspected and exported 13 September 2026; repository README.md, script.js and references/How to draw a good street map.md. Map data © OpenStreetMap contributors (ODbL), https://www.openstreetmap.org/copyright .</a:t>
-            </a:r>
+              <a:rPr dirty="0"/>
+              <a:t>Keep this slide on screen throughout the hands-on exercise. Allow about 20 minutes. Participants can work individually or in pairs. Start with a small central area and choose the SVG format for the editor. Use File &gt; Open and keep the original download. Select only the City blocks paths before changing Fill. Keep roads and water unchanged. Hide and restore a layer, then find a street label. Save a separate working copy and note one concrete observation for the discussion. Done early? Compare the map with a place you know well. If an export is delayed, use https://</a:t>
+            </a:r>
+            <a:r>
+              <a:rPr dirty="0" err="1"/>
+              <a:t>coen.at</a:t>
+            </a:r>
+            <a:r>
+              <a:rPr dirty="0"/>
+              <a:t>/</a:t>
+            </a:r>
+            <a:r>
+              <a:rPr dirty="0" err="1"/>
+              <a:t>ghent.svg</a:t>
+            </a:r>
+            <a:r>
+              <a:rPr dirty="0"/>
+              <a:t> (local backup: presentations/assets/</a:t>
+            </a:r>
+            <a:r>
+              <a:rPr dirty="0" err="1"/>
+              <a:t>ghent-demo.svg</a:t>
+            </a:r>
+            <a:r>
+              <a:rPr dirty="0"/>
+              <a:t>). Watch the progress message and try a smaller area next time. If the file looks unexpected, check SVG format, fonts and layer visibility. Useful bug reports include city, area, editor and expected result</a:t>
+            </a:r>
+            <a:r>
+              <a:rPr lang="nl-NL" dirty="0"/>
+              <a:t>.</a:t>
+            </a:r>
+            <a:endParaRPr dirty="0"/>
           </a:p>
         </p:txBody>
       </p:sp>
@@ -509,15 +531,16 @@
           <a:lstStyle/>
           <a:p>
             <a:r>
-              <a:t>End here and invite an open discussion. Collect feedback in three columns on a board or shared document: observation, impact and desired change. Capture the city, area and editor for reproducible problems. Ask for concrete examples and let other participants add their experience before prioritising. Distinguish bugs, usability issues and feature wishes. Finish by asking each person for the one improvement that matters most; do not promise delivery dates.</a:t>
-            </a:r>
-          </a:p>
-          <a:p>
-            <a:endParaRPr/>
-          </a:p>
-          <a:p>
-            <a:r>
-              <a:t>Sources: live https://coen.at/mapexport/ inspected and exported 13 September 2026; repository README.md, script.js and references/How to draw a good street map.md. Map data © OpenStreetMap contributors (ODbL), https://www.openstreetmap.org/copyright .</a:t>
+              <a:rPr dirty="0"/>
+              <a:t>End here and invite an open discussion. Collect feedback in three columns on a board or shared document: observation, impact and desired change. Capture the city, area and editor for reproducible problems. Ask for concrete examples and let other participants add their experience before </a:t>
+            </a:r>
+            <a:r>
+              <a:rPr dirty="0" err="1"/>
+              <a:t>prioritising</a:t>
+            </a:r>
+            <a:r>
+              <a:rPr dirty="0"/>
+              <a:t>. Distinguish bugs, usability issues and feature wishes. Finish by asking each person for the one improvement that matters most; do not promise delivery dates.</a:t>
             </a:r>
           </a:p>
         </p:txBody>
@@ -594,16 +617,21 @@
           <a:lstStyle/>
           <a:p>
             <a:r>
-              <a:t>Ask for a quick show of hands: who has traced a base map manually? MapExport tackles repetitive groundwork: streets, blocks and street labels. Do not promise a measured time saving. The amount of cleanup depends on the city and the source data.</a:t>
-            </a:r>
-          </a:p>
-          <a:p>
-            <a:endParaRPr/>
-          </a:p>
-          <a:p>
-            <a:r>
-              <a:t>Sources: live https://coen.at/mapexport/ inspected and exported 13 September 2026; repository README.md, script.js and references/How to draw a good street map.md. Map data © OpenStreetMap contributors (ODbL), https://www.openstreetmap.org/copyright .</a:t>
-            </a:r>
+              <a:rPr dirty="0"/>
+              <a:t>Ask for a quick show of hands: who has traced a base map manually? </a:t>
+            </a:r>
+            <a:r>
+              <a:rPr dirty="0" err="1"/>
+              <a:t>MapExport</a:t>
+            </a:r>
+            <a:r>
+              <a:rPr dirty="0"/>
+              <a:t> tackles repetitive groundwork: streets, blocks and street labels. Do not promise a measured time saving. The amount of cleanup depends on the city and the source </a:t>
+            </a:r>
+            <a:r>
+              <a:t>data.</a:t>
+            </a:r>
+            <a:endParaRPr dirty="0"/>
           </a:p>
         </p:txBody>
       </p:sp>
@@ -679,15 +707,8 @@
           <a:lstStyle/>
           <a:p>
             <a:r>
-              <a:t>Point out water, roads, parks and blocks. SVG is a vector file: it can be scaled and edited in a vector editor. This is a base map, not a complete travel guide. Sample: presentations/assets/ghent-demo.svg.</a:t>
-            </a:r>
-          </a:p>
-          <a:p>
-            <a:endParaRPr/>
-          </a:p>
-          <a:p>
-            <a:r>
-              <a:t>Sources: live https://coen.at/mapexport/ inspected and exported 13 September 2026; repository README.md, script.js and references/How to draw a good street map.md. Map data © OpenStreetMap contributors (ODbL), https://www.openstreetmap.org/copyright .</a:t>
+              <a:rPr dirty="0"/>
+              <a:t>Point out water, roads, parks and blocks. SVG is a vector file: it can be scaled and edited in a vector editor. This is a base map, not a complete travel guide. </a:t>
             </a:r>
           </a:p>
         </p:txBody>
@@ -764,16 +785,22 @@
           <a:lstStyle/>
           <a:p>
             <a:r>
-              <a:t>OpenStreetMap provides geographical data. MapExport transforms those features into a designed SVG, including computed city blocks and road labels. City blocks are areas between roads, not individual building footprints. Data coverage and quality vary by location.</a:t>
-            </a:r>
-          </a:p>
-          <a:p>
-            <a:endParaRPr/>
-          </a:p>
-          <a:p>
-            <a:r>
-              <a:t>Sources: live https://coen.at/mapexport/ inspected and exported 13 September 2026; repository README.md, script.js and references/How to draw a good street map.md. Map data © OpenStreetMap contributors (ODbL), https://www.openstreetmap.org/copyright .</a:t>
-            </a:r>
+              <a:rPr dirty="0"/>
+              <a:t>OpenStreetMap provides geographical data. </a:t>
+            </a:r>
+            <a:r>
+              <a:rPr dirty="0" err="1"/>
+              <a:t>MapExport</a:t>
+            </a:r>
+            <a:r>
+              <a:rPr dirty="0"/>
+              <a:t> transforms those features into a designed SVG, including computed city blocks and road labels. City blocks are areas between roads, not individual building footprints. Data coverage and quality vary by location</a:t>
+            </a:r>
+            <a:r>
+              <a:rPr lang="nl-NL" dirty="0"/>
+              <a:t>.</a:t>
+            </a:r>
+            <a:endParaRPr dirty="0"/>
           </a:p>
         </p:txBody>
       </p:sp>
@@ -849,15 +876,24 @@
           <a:lstStyle/>
           <a:p>
             <a:r>
-              <a:t>Open https://coen.at/mapexport/ . The controls are on the left, the map on the right. Search, pick the matching location and use Draw rectangle. Screenshot captured from the live site, 13 September 2026. Live controls may evolve.</a:t>
-            </a:r>
-          </a:p>
-          <a:p>
-            <a:endParaRPr/>
-          </a:p>
-          <a:p>
-            <a:r>
-              <a:t>Sources: live https://coen.at/mapexport/ inspected and exported 13 September 2026; repository README.md, script.js and references/How to draw a good street map.md. Map data © OpenStreetMap contributors (ODbL), https://www.openstreetmap.org/copyright .</a:t>
+              <a:rPr dirty="0"/>
+              <a:t>Open https://</a:t>
+            </a:r>
+            <a:r>
+              <a:rPr dirty="0" err="1"/>
+              <a:t>coen.at</a:t>
+            </a:r>
+            <a:r>
+              <a:rPr dirty="0"/>
+              <a:t>/</a:t>
+            </a:r>
+            <a:r>
+              <a:rPr dirty="0" err="1"/>
+              <a:t>mapexport</a:t>
+            </a:r>
+            <a:r>
+              <a:rPr dirty="0"/>
+              <a:t>/ . The controls are on the left, the map on the right. Search, pick the matching location and use Draw rectangle. Screenshot captured from the live site, 13 September 2026. Live controls may evolve</a:t>
             </a:r>
           </a:p>
         </p:txBody>
@@ -934,16 +970,22 @@
           <a:lstStyle/>
           <a:p>
             <a:r>
-              <a:t>For the first exercise choose a manageable central neighbourhood, not an entire metropolitan area. In the sample the rectangle is roughly 2.3 × 2.9 km. The live interface shows approximate printed dimensions. Avoid implying that the website has an A3 selector. A larger export has more objects and may take longer.</a:t>
-            </a:r>
-          </a:p>
-          <a:p>
-            <a:endParaRPr/>
-          </a:p>
-          <a:p>
-            <a:r>
-              <a:t>Sources: live https://coen.at/mapexport/ inspected and exported 13 September 2026; repository README.md, script.js and references/How to draw a good street map.md. Map data © OpenStreetMap contributors (ODbL), https://www.openstreetmap.org/copyright .</a:t>
-            </a:r>
+              <a:rPr dirty="0"/>
+              <a:t>For the first exercise choose a manageable central </a:t>
+            </a:r>
+            <a:r>
+              <a:rPr dirty="0" err="1"/>
+              <a:t>neighbourhood</a:t>
+            </a:r>
+            <a:r>
+              <a:rPr dirty="0"/>
+              <a:t>, not an entire metropolitan area. In the sample the rectangle is roughly 2.3 × 2.9 km. The live interface shows approximate printed dimensions. Avoid implying that the website has an A3 selector. A larger export has more objects and may take longer</a:t>
+            </a:r>
+            <a:r>
+              <a:rPr lang="nl-NL" dirty="0"/>
+              <a:t>.</a:t>
+            </a:r>
+            <a:endParaRPr dirty="0"/>
           </a:p>
         </p:txBody>
       </p:sp>
@@ -1019,15 +1061,8 @@
           <a:lstStyle/>
           <a:p>
             <a:r>
+              <a:rPr dirty="0"/>
               <a:t>Show the layer checkboxes on the live site. Available options include water bodies, waterways, city blocks, parks/green space, roads, railways and transit features. Street-name controls include road categories. Explain that all available detail does not necessarily improve a printed USE-IT map. City blocks do not represent each individual building.</a:t>
-            </a:r>
-          </a:p>
-          <a:p>
-            <a:endParaRPr/>
-          </a:p>
-          <a:p>
-            <a:r>
-              <a:t>Sources: live https://coen.at/mapexport/ inspected and exported 13 September 2026; repository README.md, script.js and references/How to draw a good street map.md. Map data © OpenStreetMap contributors (ODbL), https://www.openstreetmap.org/copyright .</a:t>
             </a:r>
           </a:p>
         </p:txBody>
@@ -1104,16 +1139,14 @@
           <a:lstStyle/>
           <a:p>
             <a:r>
-              <a:t>These are the option labels observed on the live site. Use File &gt; Open, rather than placing the SVG as a linked image in another document. Inspect Layers or Layers and Objects after opening; group/layer presentation differs between editors. Keep the original SVG for recovery.</a:t>
-            </a:r>
-          </a:p>
-          <a:p>
-            <a:endParaRPr/>
-          </a:p>
-          <a:p>
-            <a:r>
-              <a:t>Sources: live https://coen.at/mapexport/ inspected and exported 13 September 2026; repository README.md, script.js and references/How to draw a good street map.md. Map data © OpenStreetMap contributors (ODbL), https://www.openstreetmap.org/copyright .</a:t>
-            </a:r>
+              <a:rPr dirty="0"/>
+              <a:t>These are the option labels observed on the live site. Use File &gt; Open, rather than placing the SVG as a linked image in another document. Inspect Layers or Layers and Objects after opening; group/layer presentation differs between editors. Keep the original SVG for recovery</a:t>
+            </a:r>
+            <a:r>
+              <a:rPr lang="nl-NL" dirty="0"/>
+              <a:t>.</a:t>
+            </a:r>
+            <a:endParaRPr dirty="0"/>
           </a:p>
         </p:txBody>
       </p:sp>
@@ -1189,31 +1222,44 @@
           <a:lstStyle/>
           <a:p>
             <a:r>
+              <a:rPr dirty="0"/>
               <a:t>DEMO SCRIPT</a:t>
             </a:r>
           </a:p>
           <a:p>
             <a:r>
-              <a:t>Open presentations/assets/ghent-demo.svg in Inkscape. Fit the page to the window (5). Open Layer &gt; Layers and Objects and expand Map content. Find City blocks. Enter that layer and select its child paths, or select one block and use Edit &gt; Select Same &gt; Fill Color. Verify that only the city-block paths are selected: this sample contains 581. Lock unrelated layers first if their objects share the same fill. Click a palette colour or use Object &gt; Fill and Stroke to change Fill (do not Shift-click, which changes Stroke). Water, roads and parks should retain their colours. Undo once to show that all blocks changed together. Save a separate edited SVG.</a:t>
-            </a:r>
-          </a:p>
-          <a:p>
-            <a:r>
-              <a:t>The preview on the right changes every child path in city_blocks to #F2CA76 and nothing else. It was rendered by Inkscape from the actual export. This slide is a prompt to switch to a live editor, not a recording of UI clicks. Backup: ghent-recoloured.svg.</a:t>
-            </a:r>
-          </a:p>
-          <a:p>
-            <a:r>
-              <a:t>Inkscape Select Same documentation: https://inkscape.org/en/doc/tutorials/basic/tutorial-basic.pt_BR.html/ .</a:t>
-            </a:r>
-          </a:p>
-          <a:p>
-            <a:endParaRPr/>
-          </a:p>
-          <a:p>
-            <a:r>
-              <a:t>Sources: live https://coen.at/mapexport/ inspected and exported 13 September 2026; repository README.md, script.js and references/How to draw a good street map.md. Map data © OpenStreetMap contributors (ODbL), https://www.openstreetmap.org/copyright .</a:t>
-            </a:r>
+              <a:rPr dirty="0"/>
+              <a:t>Open presentations/assets/</a:t>
+            </a:r>
+            <a:r>
+              <a:rPr dirty="0" err="1"/>
+              <a:t>ghent-demo.svg</a:t>
+            </a:r>
+            <a:r>
+              <a:rPr dirty="0"/>
+              <a:t> in Inkscape. Fit the page to the window (5). Open Layer &gt; Layers and Objects and expand Map content. Find City blocks. Enter that layer and select its child paths, or select one block and use Edit &gt; Select Same &gt; Fill Color. Verify that only the city-block paths are selected: this sample contains 581. Lock unrelated layers first if their objects share the same fill. Click a palette </a:t>
+            </a:r>
+            <a:r>
+              <a:rPr dirty="0" err="1"/>
+              <a:t>colour</a:t>
+            </a:r>
+            <a:r>
+              <a:rPr dirty="0"/>
+              <a:t> or use Object &gt; Fill and Stroke to change Fill (do not Shift-click, which changes Stroke). Water, roads and parks should retain their </a:t>
+            </a:r>
+            <a:r>
+              <a:rPr dirty="0" err="1"/>
+              <a:t>colours</a:t>
+            </a:r>
+            <a:r>
+              <a:rPr dirty="0"/>
+              <a:t>. Undo once to show that all blocks changed together. Save a separate edited SVG</a:t>
+            </a:r>
+            <a:r>
+              <a:rPr lang="nl-NL" dirty="0"/>
+              <a:t>.</a:t>
+            </a:r>
+            <a:endParaRPr dirty="0"/>
           </a:p>
         </p:txBody>
       </p:sp>
@@ -5388,8 +5434,27 @@
                 <a:ea typeface="Mayonnaise Black"/>
                 <a:cs typeface="Mayonnaise Black"/>
               </a:rPr>
-              <a:t> BASE MAP YOU CAN MAKE YOUR OWN</a:t>
-            </a:r>
+              <a:t> BASE MAP YOU CAN </a:t>
+            </a:r>
+            <a:r>
+              <a:rPr lang="nl-NL" sz="4125" dirty="0">
+                <a:solidFill>
+                  <a:srgbClr val="18180F"/>
+                </a:solidFill>
+                <a:latin typeface="Mayonnaise Black"/>
+                <a:ea typeface="Mayonnaise Black"/>
+                <a:cs typeface="Mayonnaise Black"/>
+              </a:rPr>
+              <a:t>EDIT</a:t>
+            </a:r>
+            <a:endParaRPr sz="4125" b="0" dirty="0">
+              <a:solidFill>
+                <a:srgbClr val="18180F"/>
+              </a:solidFill>
+              <a:latin typeface="Mayonnaise Black"/>
+              <a:ea typeface="Mayonnaise Black"/>
+              <a:cs typeface="Mayonnaise Black"/>
+            </a:endParaRPr>
           </a:p>
         </p:txBody>
       </p:sp>
@@ -6882,7 +6947,7 @@
               </a:defRPr>
             </a:pPr>
             <a:r>
-              <a:rPr sz="4125" b="0">
+              <a:rPr lang="nl-NL" sz="4125" b="0" dirty="0">
                 <a:solidFill>
                   <a:srgbClr val="18180F"/>
                 </a:solidFill>
@@ -6890,8 +6955,16 @@
                 <a:ea typeface="Mayonnaise Black"/>
                 <a:cs typeface="Mayonnaise Black"/>
               </a:rPr>
-              <a:t>MEET YOUR WORKSPACE</a:t>
-            </a:r>
+              <a:t>HOW IT WORKS</a:t>
+            </a:r>
+            <a:endParaRPr sz="4125" b="0" dirty="0">
+              <a:solidFill>
+                <a:srgbClr val="18180F"/>
+              </a:solidFill>
+              <a:latin typeface="Mayonnaise Black"/>
+              <a:ea typeface="Mayonnaise Black"/>
+              <a:cs typeface="Mayonnaise Black"/>
+            </a:endParaRPr>
           </a:p>
         </p:txBody>
       </p:sp>
@@ -6939,15 +7012,15 @@
               </a:defRPr>
             </a:pPr>
             <a:r>
-              <a:rPr sz="1125" b="0">
-                <a:solidFill>
-                  <a:srgbClr val="18180F"/>
-                </a:solidFill>
-                <a:latin typeface="Apfel Grotezk"/>
-                <a:ea typeface="Apfel Grotezk"/>
-                <a:cs typeface="Apfel Grotezk"/>
-              </a:rPr>
-              <a:t>MAPEXPORT  /  USE-IT     ·     Map data © OpenStreetMap contributors</a:t>
+              <a:rPr sz="1125" b="0" dirty="0">
+                <a:solidFill>
+                  <a:srgbClr val="18180F"/>
+                </a:solidFill>
+                <a:latin typeface="Apfel Grotezk"/>
+                <a:ea typeface="Apfel Grotezk"/>
+                <a:cs typeface="Apfel Grotezk"/>
+              </a:rPr>
+              <a:t>MAPEXPORT  /  USE-IT </a:t>
             </a:r>
           </a:p>
         </p:txBody>

</xml_diff>